<commit_message>
Add references slide to the Interspeech 2026 deck
Appends a final slide listing the paper's 28 references in the paper's
numbering, laid out in two columns; updates README and talk script and
refreshes the PDF export.

Co-Authored-By: Claude Fable 5.1 <noreply@anthropic.com>
Claude-Session: https://claude.ai/code/session_01MbMqhsHfGDgMztoj6KvhmM
</commit_message>
<xml_diff>
--- a/presentation/Audio2Tool_Interspeech2026_Oral.pptx
+++ b/presentation/Audio2Tool_Interspeech2026_Oral.pptx
@@ -26,9 +26,10 @@
     <p:sldId id="274" r:id="rId20"/>
     <p:sldId id="275" r:id="rId21"/>
     <p:sldId id="276" r:id="rId22"/>
+    <p:sldId id="277" r:id="rId23"/>
   </p:sldIdLst>
   <p:notesMasterIdLst>
-    <p:notesMasterId r:id="rId23"/>
+    <p:notesMasterId r:id="rId24"/>
   </p:notesMasterIdLst>
   <p:sldSz cx="12192000" cy="6858000"/>
   <p:notesSz cx="6858000" cy="12192000"/>
@@ -4748,6 +4749,94 @@
             <a:fld id="{F7021451-1387-4CA6-816F-3879F97B5CBC}" type="slidenum">
               <a:rPr lang="en-US"/>
               <a:t>21</a:t>
+            </a:fld>
+            <a:endParaRPr lang="en-US"/>
+          </a:p>
+        </p:txBody>
+      </p:sp>
+    </p:spTree>
+    <p:extLst>
+      <p:ext uri="{BB962C8B-B14F-4D97-AF65-F5344CB8AC3E}">
+        <p14:creationId xmlns:p14="http://schemas.microsoft.com/office/powerpoint/2010/main" val="1024086991"/>
+      </p:ext>
+    </p:extLst>
+  </p:cSld>
+  <p:clrMapOvr>
+    <a:masterClrMapping/>
+  </p:clrMapOvr>
+</p:notes>
+</file>
+
+<file path=ppt/notesSlides/notesSlide22.xml><?xml version="1.0" encoding="utf-8"?>
+<p:notes xmlns:a="http://schemas.openxmlformats.org/drawingml/2006/main" xmlns:r="http://schemas.openxmlformats.org/officeDocument/2006/relationships" xmlns:p="http://schemas.openxmlformats.org/presentationml/2006/main">
+  <p:cSld>
+    <p:spTree>
+      <p:nvGrpSpPr>
+        <p:cNvPr id="1" name=""/>
+        <p:cNvGrpSpPr/>
+        <p:nvPr/>
+      </p:nvGrpSpPr>
+      <p:grpSpPr>
+        <a:xfrm>
+          <a:off x="0" y="0"/>
+          <a:ext cx="0" cy="0"/>
+          <a:chOff x="0" y="0"/>
+          <a:chExt cx="0" cy="0"/>
+        </a:xfrm>
+      </p:grpSpPr>
+      <p:sp>
+        <p:nvSpPr>
+          <p:cNvPr id="2" name="Slide Image Placeholder 1"/>
+          <p:cNvSpPr>
+            <a:spLocks noGrp="1" noRot="1" noChangeAspect="1"/>
+          </p:cNvSpPr>
+          <p:nvPr>
+            <p:ph type="sldImg"/>
+          </p:nvPr>
+        </p:nvSpPr>
+        <p:spPr/>
+      </p:sp>
+      <p:sp>
+        <p:nvSpPr>
+          <p:cNvPr id="3" name="Notes Placeholder 2"/>
+          <p:cNvSpPr>
+            <a:spLocks noGrp="1"/>
+          </p:cNvSpPr>
+          <p:nvPr>
+            <p:ph type="body" idx="1"/>
+          </p:nvPr>
+        </p:nvSpPr>
+        <p:spPr/>
+        <p:txBody>
+          <a:bodyPr/>
+          <a:lstStyle/>
+          <a:p>
+            <a:r>
+              <a:rPr lang="en-US" dirty="0"/>
+              <a:t>References cited in the paper, in the paper's numbering. Not spoken; here for the audience and for Q&amp;A.</a:t>
+            </a:r>
+            <a:endParaRPr lang="en-US" dirty="0"/>
+          </a:p>
+        </p:txBody>
+      </p:sp>
+      <p:sp>
+        <p:nvSpPr>
+          <p:cNvPr id="4" name="Slide Number Placeholder 3"/>
+          <p:cNvSpPr>
+            <a:spLocks noGrp="1"/>
+          </p:cNvSpPr>
+          <p:nvPr>
+            <p:ph type="sldNum" sz="quarter" idx="10"/>
+          </p:nvPr>
+        </p:nvSpPr>
+        <p:spPr/>
+        <p:txBody>
+          <a:bodyPr/>
+          <a:lstStyle/>
+          <a:p>
+            <a:fld id="{F7021451-1387-4CA6-816F-3879F97B5CBC}" type="slidenum">
+              <a:rPr lang="en-US"/>
+              <a:t>22</a:t>
             </a:fld>
             <a:endParaRPr lang="en-US"/>
           </a:p>
@@ -24310,6 +24399,2790 @@
 </p:sld>
 </file>
 
+<file path=ppt/slides/slide22.xml><?xml version="1.0" encoding="utf-8"?>
+<p:sld xmlns:a="http://schemas.openxmlformats.org/drawingml/2006/main" xmlns:r="http://schemas.openxmlformats.org/officeDocument/2006/relationships" xmlns:p="http://schemas.openxmlformats.org/presentationml/2006/main">
+  <p:cSld name="Slide 22">
+    <p:bg>
+      <p:bgPr>
+        <a:solidFill>
+          <a:srgbClr val="FFFFFF"/>
+        </a:solidFill>
+      </p:bgPr>
+    </p:bg>
+    <p:spTree>
+      <p:nvGrpSpPr>
+        <p:cNvPr id="1" name=""/>
+        <p:cNvGrpSpPr/>
+        <p:nvPr/>
+      </p:nvGrpSpPr>
+      <p:grpSpPr>
+        <a:xfrm>
+          <a:off x="0" y="0"/>
+          <a:ext cx="0" cy="0"/>
+          <a:chOff x="0" y="0"/>
+          <a:chExt cx="0" cy="0"/>
+        </a:xfrm>
+      </p:grpSpPr>
+      <p:sp>
+        <p:nvSpPr>
+          <p:cNvPr id="2" name="Text 0"/>
+          <p:cNvSpPr txBox="1"/>
+          <p:nvPr/>
+        </p:nvSpPr>
+        <p:spPr>
+          <a:xfrm>
+            <a:off x="548640" y="310896"/>
+            <a:ext cx="7315200" cy="274320"/>
+          </a:xfrm>
+          <a:prstGeom prst="rect">
+            <a:avLst/>
+          </a:prstGeom>
+          <a:noFill/>
+          <a:ln/>
+        </p:spPr>
+        <p:txBody>
+          <a:bodyPr wrap="square" lIns="0" tIns="0" rIns="0" bIns="0" rtlCol="0" anchor="t"/>
+          <a:lstStyle/>
+          <a:p>
+            <a:pPr indent="0" marL="0">
+              <a:buNone/>
+            </a:pPr>
+            <a:r>
+              <a:rPr lang="en-US" sz="1200" b="1" spc="300" kern="0" dirty="0">
+                <a:solidFill>
+                  <a:srgbClr val="5B6B7F"/>
+                </a:solidFill>
+                <a:latin typeface="Calibri" pitchFamily="34" charset="0"/>
+                <a:ea typeface="Calibri" pitchFamily="34" charset="-122"/>
+                <a:cs typeface="Calibri" pitchFamily="34" charset="-120"/>
+              </a:rPr>
+              <a:t>REFERENCES</a:t>
+            </a:r>
+            <a:endParaRPr lang="en-US" sz="1200" dirty="0"/>
+          </a:p>
+        </p:txBody>
+      </p:sp>
+      <p:sp>
+        <p:nvSpPr>
+          <p:cNvPr id="3" name="Text 1"/>
+          <p:cNvSpPr txBox="1"/>
+          <p:nvPr/>
+        </p:nvSpPr>
+        <p:spPr>
+          <a:xfrm>
+            <a:off x="548640" y="548640"/>
+            <a:ext cx="10332720" cy="914400"/>
+          </a:xfrm>
+          <a:prstGeom prst="rect">
+            <a:avLst/>
+          </a:prstGeom>
+          <a:noFill/>
+          <a:ln/>
+        </p:spPr>
+        <p:txBody>
+          <a:bodyPr wrap="square" lIns="0" tIns="0" rIns="0" bIns="0" rtlCol="0" anchor="t"/>
+          <a:lstStyle/>
+          <a:p>
+            <a:pPr indent="0" marL="0">
+              <a:buNone/>
+            </a:pPr>
+            <a:r>
+              <a:rPr lang="en-US" sz="2800" b="1" dirty="0">
+                <a:solidFill>
+                  <a:srgbClr val="0F1B2D"/>
+                </a:solidFill>
+                <a:latin typeface="Calibri" pitchFamily="34" charset="0"/>
+                <a:ea typeface="Calibri" pitchFamily="34" charset="-122"/>
+                <a:cs typeface="Calibri" pitchFamily="34" charset="-120"/>
+              </a:rPr>
+              <a:t>References</a:t>
+            </a:r>
+            <a:endParaRPr lang="en-US" sz="2800" dirty="0"/>
+          </a:p>
+        </p:txBody>
+      </p:sp>
+      <p:sp>
+        <p:nvSpPr>
+          <p:cNvPr id="4" name="Shape 2"/>
+          <p:cNvSpPr/>
+          <p:nvPr/>
+        </p:nvSpPr>
+        <p:spPr>
+          <a:xfrm>
+            <a:off x="11018520" y="536296"/>
+            <a:ext cx="50189" cy="134417"/>
+          </a:xfrm>
+          <a:prstGeom prst="roundRect">
+            <a:avLst>
+              <a:gd name="adj" fmla="val 50000"/>
+            </a:avLst>
+          </a:prstGeom>
+          <a:solidFill>
+            <a:srgbClr val="0FA3B1"/>
+          </a:solidFill>
+          <a:ln w="12700">
+            <a:solidFill>
+              <a:srgbClr val="0FA3B1"/>
+            </a:solidFill>
+            <a:prstDash val="solid"/>
+          </a:ln>
+        </p:spPr>
+      </p:sp>
+      <p:sp>
+        <p:nvSpPr>
+          <p:cNvPr id="5" name="Shape 3"/>
+          <p:cNvSpPr/>
+          <p:nvPr/>
+        </p:nvSpPr>
+        <p:spPr>
+          <a:xfrm>
+            <a:off x="11116835" y="469087"/>
+            <a:ext cx="50189" cy="268834"/>
+          </a:xfrm>
+          <a:prstGeom prst="roundRect">
+            <a:avLst>
+              <a:gd name="adj" fmla="val 50000"/>
+            </a:avLst>
+          </a:prstGeom>
+          <a:solidFill>
+            <a:srgbClr val="0FA3B1"/>
+          </a:solidFill>
+          <a:ln w="12700">
+            <a:solidFill>
+              <a:srgbClr val="0FA3B1"/>
+            </a:solidFill>
+            <a:prstDash val="solid"/>
+          </a:ln>
+        </p:spPr>
+      </p:sp>
+      <p:sp>
+        <p:nvSpPr>
+          <p:cNvPr id="6" name="Shape 4"/>
+          <p:cNvSpPr/>
+          <p:nvPr/>
+        </p:nvSpPr>
+        <p:spPr>
+          <a:xfrm>
+            <a:off x="11215150" y="411480"/>
+            <a:ext cx="50189" cy="384048"/>
+          </a:xfrm>
+          <a:prstGeom prst="roundRect">
+            <a:avLst>
+              <a:gd name="adj" fmla="val 50000"/>
+            </a:avLst>
+          </a:prstGeom>
+          <a:solidFill>
+            <a:srgbClr val="0FA3B1"/>
+          </a:solidFill>
+          <a:ln w="12700">
+            <a:solidFill>
+              <a:srgbClr val="0FA3B1"/>
+            </a:solidFill>
+            <a:prstDash val="solid"/>
+          </a:ln>
+        </p:spPr>
+      </p:sp>
+      <p:sp>
+        <p:nvSpPr>
+          <p:cNvPr id="7" name="Shape 5"/>
+          <p:cNvSpPr/>
+          <p:nvPr/>
+        </p:nvSpPr>
+        <p:spPr>
+          <a:xfrm>
+            <a:off x="11313466" y="488290"/>
+            <a:ext cx="50189" cy="230429"/>
+          </a:xfrm>
+          <a:prstGeom prst="roundRect">
+            <a:avLst>
+              <a:gd name="adj" fmla="val 50000"/>
+            </a:avLst>
+          </a:prstGeom>
+          <a:solidFill>
+            <a:srgbClr val="0FA3B1"/>
+          </a:solidFill>
+          <a:ln w="12700">
+            <a:solidFill>
+              <a:srgbClr val="0FA3B1"/>
+            </a:solidFill>
+            <a:prstDash val="solid"/>
+          </a:ln>
+        </p:spPr>
+      </p:sp>
+      <p:sp>
+        <p:nvSpPr>
+          <p:cNvPr id="8" name="Shape 6"/>
+          <p:cNvSpPr/>
+          <p:nvPr/>
+        </p:nvSpPr>
+        <p:spPr>
+          <a:xfrm>
+            <a:off x="11411781" y="440284"/>
+            <a:ext cx="50189" cy="326441"/>
+          </a:xfrm>
+          <a:prstGeom prst="roundRect">
+            <a:avLst>
+              <a:gd name="adj" fmla="val 50000"/>
+            </a:avLst>
+          </a:prstGeom>
+          <a:solidFill>
+            <a:srgbClr val="0FA3B1"/>
+          </a:solidFill>
+          <a:ln w="12700">
+            <a:solidFill>
+              <a:srgbClr val="0FA3B1"/>
+            </a:solidFill>
+            <a:prstDash val="solid"/>
+          </a:ln>
+        </p:spPr>
+      </p:sp>
+      <p:sp>
+        <p:nvSpPr>
+          <p:cNvPr id="9" name="Shape 7"/>
+          <p:cNvSpPr/>
+          <p:nvPr/>
+        </p:nvSpPr>
+        <p:spPr>
+          <a:xfrm>
+            <a:off x="11510096" y="517093"/>
+            <a:ext cx="50189" cy="172822"/>
+          </a:xfrm>
+          <a:prstGeom prst="roundRect">
+            <a:avLst>
+              <a:gd name="adj" fmla="val 50000"/>
+            </a:avLst>
+          </a:prstGeom>
+          <a:solidFill>
+            <a:srgbClr val="0FA3B1"/>
+          </a:solidFill>
+          <a:ln w="12700">
+            <a:solidFill>
+              <a:srgbClr val="0FA3B1"/>
+            </a:solidFill>
+            <a:prstDash val="solid"/>
+          </a:ln>
+        </p:spPr>
+      </p:sp>
+      <p:sp>
+        <p:nvSpPr>
+          <p:cNvPr id="10" name="Shape 8"/>
+          <p:cNvSpPr/>
+          <p:nvPr/>
+        </p:nvSpPr>
+        <p:spPr>
+          <a:xfrm>
+            <a:off x="11608411" y="555498"/>
+            <a:ext cx="50189" cy="96012"/>
+          </a:xfrm>
+          <a:prstGeom prst="roundRect">
+            <a:avLst>
+              <a:gd name="adj" fmla="val 50000"/>
+            </a:avLst>
+          </a:prstGeom>
+          <a:solidFill>
+            <a:srgbClr val="0FA3B1"/>
+          </a:solidFill>
+          <a:ln w="12700">
+            <a:solidFill>
+              <a:srgbClr val="0FA3B1"/>
+            </a:solidFill>
+            <a:prstDash val="solid"/>
+          </a:ln>
+        </p:spPr>
+      </p:sp>
+      <p:sp>
+        <p:nvSpPr>
+          <p:cNvPr id="11" name="Text 9"/>
+          <p:cNvSpPr txBox="1"/>
+          <p:nvPr/>
+        </p:nvSpPr>
+        <p:spPr>
+          <a:xfrm>
+            <a:off x="548640" y="6473952"/>
+            <a:ext cx="6400800" cy="256032"/>
+          </a:xfrm>
+          <a:prstGeom prst="rect">
+            <a:avLst/>
+          </a:prstGeom>
+          <a:noFill/>
+          <a:ln/>
+        </p:spPr>
+        <p:txBody>
+          <a:bodyPr wrap="square" lIns="0" tIns="0" rIns="0" bIns="0" rtlCol="0" anchor="t"/>
+          <a:lstStyle/>
+          <a:p>
+            <a:pPr indent="0" marL="0">
+              <a:buNone/>
+            </a:pPr>
+            <a:r>
+              <a:rPr lang="en-US" sz="1000" dirty="0">
+                <a:solidFill>
+                  <a:srgbClr val="8A97A8"/>
+                </a:solidFill>
+                <a:latin typeface="Calibri" pitchFamily="34" charset="0"/>
+                <a:ea typeface="Calibri" pitchFamily="34" charset="-122"/>
+                <a:cs typeface="Calibri" pitchFamily="34" charset="-120"/>
+              </a:rPr>
+              <a:t>Audio2Tool  ·  Interspeech 2026  ·  Sydney</a:t>
+            </a:r>
+            <a:endParaRPr lang="en-US" sz="1000" dirty="0"/>
+          </a:p>
+        </p:txBody>
+      </p:sp>
+      <p:sp>
+        <p:nvSpPr>
+          <p:cNvPr id="12" name="Text 10"/>
+          <p:cNvSpPr txBox="1"/>
+          <p:nvPr/>
+        </p:nvSpPr>
+        <p:spPr>
+          <a:xfrm>
+            <a:off x="11109960" y="6473952"/>
+            <a:ext cx="530352" cy="256032"/>
+          </a:xfrm>
+          <a:prstGeom prst="rect">
+            <a:avLst/>
+          </a:prstGeom>
+          <a:noFill/>
+          <a:ln/>
+        </p:spPr>
+        <p:txBody>
+          <a:bodyPr wrap="square" lIns="0" tIns="0" rIns="0" bIns="0" rtlCol="0" anchor="t"/>
+          <a:lstStyle/>
+          <a:p>
+            <a:pPr algn="r" indent="0" marL="0">
+              <a:buNone/>
+            </a:pPr>
+            <a:r>
+              <a:rPr lang="en-US" sz="1000" dirty="0">
+                <a:solidFill>
+                  <a:srgbClr val="8A97A8"/>
+                </a:solidFill>
+                <a:latin typeface="Calibri" pitchFamily="34" charset="0"/>
+                <a:ea typeface="Calibri" pitchFamily="34" charset="-122"/>
+                <a:cs typeface="Calibri" pitchFamily="34" charset="-120"/>
+              </a:rPr>
+              <a:t>22</a:t>
+            </a:r>
+            <a:endParaRPr lang="en-US" sz="1000" dirty="0"/>
+          </a:p>
+        </p:txBody>
+      </p:sp>
+      <p:sp>
+        <p:nvSpPr>
+          <p:cNvPr id="14" name="Text 11"/>
+          <p:cNvSpPr txBox="1"/>
+          <p:nvPr/>
+        </p:nvSpPr>
+        <p:spPr>
+          <a:xfrm>
+            <a:off x="548640" y="1463040"/>
+            <a:ext cx="5468112" cy="4892040"/>
+          </a:xfrm>
+          <a:prstGeom prst="rect">
+            <a:avLst/>
+          </a:prstGeom>
+          <a:noFill/>
+          <a:ln/>
+        </p:spPr>
+        <p:txBody>
+          <a:bodyPr wrap="square" lIns="0" tIns="0" rIns="0" bIns="0" rtlCol="0" anchor="t"/>
+          <a:lstStyle/>
+          <a:p>
+            <a:pPr indent="0" marL="0">
+              <a:lnSpc>
+                <a:spcPct val="105000"/>
+              </a:lnSpc>
+              <a:spcAft>
+                <a:spcPts val="300"/>
+              </a:spcAft>
+              <a:buNone/>
+            </a:pPr>
+            <a:r>
+              <a:rPr lang="en-US" sz="950" b="1" dirty="0">
+                <a:solidFill>
+                  <a:srgbClr val="0B7F8A"/>
+                </a:solidFill>
+                <a:latin typeface="Calibri" pitchFamily="34" charset="0"/>
+                <a:ea typeface="Calibri" pitchFamily="34" charset="-122"/>
+                <a:cs typeface="Calibri" pitchFamily="34" charset="-120"/>
+              </a:rPr>
+              <a:t>[1]  </a:t>
+            </a:r>
+            <a:pPr indent="0" marL="0">
+              <a:lnSpc>
+                <a:spcPct val="105000"/>
+              </a:lnSpc>
+              <a:spcAft>
+                <a:spcPts val="300"/>
+              </a:spcAft>
+              <a:buNone/>
+            </a:pPr>
+            <a:r>
+              <a:rPr lang="en-US" sz="950" dirty="0">
+                <a:solidFill>
+                  <a:srgbClr val="1B2A41"/>
+                </a:solidFill>
+                <a:latin typeface="Calibri" pitchFamily="34" charset="0"/>
+                <a:ea typeface="Calibri" pitchFamily="34" charset="-122"/>
+                <a:cs typeface="Calibri" pitchFamily="34" charset="-120"/>
+              </a:rPr>
+              <a:t>Chen, Yue, Zhang, Gao, Tan, Li. </a:t>
+            </a:r>
+            <a:pPr indent="0" marL="0">
+              <a:lnSpc>
+                <a:spcPct val="105000"/>
+              </a:lnSpc>
+              <a:spcAft>
+                <a:spcPts val="300"/>
+              </a:spcAft>
+              <a:buNone/>
+            </a:pPr>
+            <a:r>
+              <a:rPr lang="en-US" sz="950" dirty="0">
+                <a:solidFill>
+                  <a:srgbClr val="0F1B2D"/>
+                </a:solidFill>
+                <a:latin typeface="Calibri" pitchFamily="34" charset="0"/>
+                <a:ea typeface="Calibri" pitchFamily="34" charset="-122"/>
+                <a:cs typeface="Calibri" pitchFamily="34" charset="-120"/>
+              </a:rPr>
+              <a:t>VoiceBench: Benchmarking LLM-based voice assistants. </a:t>
+            </a:r>
+            <a:pPr indent="0" marL="0">
+              <a:lnSpc>
+                <a:spcPct val="105000"/>
+              </a:lnSpc>
+              <a:spcAft>
+                <a:spcPts val="300"/>
+              </a:spcAft>
+              <a:buNone/>
+            </a:pPr>
+            <a:r>
+              <a:rPr lang="en-US" sz="950" i="1" dirty="0">
+                <a:solidFill>
+                  <a:srgbClr val="5B6B7F"/>
+                </a:solidFill>
+                <a:latin typeface="Calibri" pitchFamily="34" charset="0"/>
+                <a:ea typeface="Calibri" pitchFamily="34" charset="-122"/>
+                <a:cs typeface="Calibri" pitchFamily="34" charset="-120"/>
+              </a:rPr>
+              <a:t>arXiv:2410.17196, 2024</a:t>
+            </a:r>
+            <a:endParaRPr lang="en-US" sz="950" dirty="0"/>
+          </a:p>
+          <a:p>
+            <a:pPr indent="0" marL="0">
+              <a:lnSpc>
+                <a:spcPct val="105000"/>
+              </a:lnSpc>
+              <a:spcAft>
+                <a:spcPts val="300"/>
+              </a:spcAft>
+              <a:buNone/>
+            </a:pPr>
+            <a:r>
+              <a:rPr lang="en-US" sz="950" b="1" dirty="0">
+                <a:solidFill>
+                  <a:srgbClr val="0B7F8A"/>
+                </a:solidFill>
+                <a:latin typeface="Calibri" pitchFamily="34" charset="0"/>
+                <a:ea typeface="Calibri" pitchFamily="34" charset="-122"/>
+                <a:cs typeface="Calibri" pitchFamily="34" charset="-120"/>
+              </a:rPr>
+              <a:t>[2]  </a:t>
+            </a:r>
+            <a:pPr indent="0" marL="0">
+              <a:lnSpc>
+                <a:spcPct val="105000"/>
+              </a:lnSpc>
+              <a:spcAft>
+                <a:spcPts val="300"/>
+              </a:spcAft>
+              <a:buNone/>
+            </a:pPr>
+            <a:r>
+              <a:rPr lang="en-US" sz="950" dirty="0">
+                <a:solidFill>
+                  <a:srgbClr val="1B2A41"/>
+                </a:solidFill>
+                <a:latin typeface="Calibri" pitchFamily="34" charset="0"/>
+                <a:ea typeface="Calibri" pitchFamily="34" charset="-122"/>
+                <a:cs typeface="Calibri" pitchFamily="34" charset="-120"/>
+              </a:rPr>
+              <a:t>Zhong, Du, Zhang, Hu, Tang. </a:t>
+            </a:r>
+            <a:pPr indent="0" marL="0">
+              <a:lnSpc>
+                <a:spcPct val="105000"/>
+              </a:lnSpc>
+              <a:spcAft>
+                <a:spcPts val="300"/>
+              </a:spcAft>
+              <a:buNone/>
+            </a:pPr>
+            <a:r>
+              <a:rPr lang="en-US" sz="950" dirty="0">
+                <a:solidFill>
+                  <a:srgbClr val="0F1B2D"/>
+                </a:solidFill>
+                <a:latin typeface="Calibri" pitchFamily="34" charset="0"/>
+                <a:ea typeface="Calibri" pitchFamily="34" charset="-122"/>
+                <a:cs typeface="Calibri" pitchFamily="34" charset="-120"/>
+              </a:rPr>
+              <a:t>ComplexFuncBench: Multi-step and constrained function calling under long-context scenario. </a:t>
+            </a:r>
+            <a:pPr indent="0" marL="0">
+              <a:lnSpc>
+                <a:spcPct val="105000"/>
+              </a:lnSpc>
+              <a:spcAft>
+                <a:spcPts val="300"/>
+              </a:spcAft>
+              <a:buNone/>
+            </a:pPr>
+            <a:r>
+              <a:rPr lang="en-US" sz="950" i="1" dirty="0">
+                <a:solidFill>
+                  <a:srgbClr val="5B6B7F"/>
+                </a:solidFill>
+                <a:latin typeface="Calibri" pitchFamily="34" charset="0"/>
+                <a:ea typeface="Calibri" pitchFamily="34" charset="-122"/>
+                <a:cs typeface="Calibri" pitchFamily="34" charset="-120"/>
+              </a:rPr>
+              <a:t>arXiv:2501.10132, 2025</a:t>
+            </a:r>
+            <a:endParaRPr lang="en-US" sz="950" dirty="0"/>
+          </a:p>
+          <a:p>
+            <a:pPr indent="0" marL="0">
+              <a:lnSpc>
+                <a:spcPct val="105000"/>
+              </a:lnSpc>
+              <a:spcAft>
+                <a:spcPts val="300"/>
+              </a:spcAft>
+              <a:buNone/>
+            </a:pPr>
+            <a:r>
+              <a:rPr lang="en-US" sz="950" b="1" dirty="0">
+                <a:solidFill>
+                  <a:srgbClr val="0B7F8A"/>
+                </a:solidFill>
+                <a:latin typeface="Calibri" pitchFamily="34" charset="0"/>
+                <a:ea typeface="Calibri" pitchFamily="34" charset="-122"/>
+                <a:cs typeface="Calibri" pitchFamily="34" charset="-120"/>
+              </a:rPr>
+              <a:t>[3]  </a:t>
+            </a:r>
+            <a:pPr indent="0" marL="0">
+              <a:lnSpc>
+                <a:spcPct val="105000"/>
+              </a:lnSpc>
+              <a:spcAft>
+                <a:spcPts val="300"/>
+              </a:spcAft>
+              <a:buNone/>
+            </a:pPr>
+            <a:r>
+              <a:rPr lang="en-US" sz="950" dirty="0">
+                <a:solidFill>
+                  <a:srgbClr val="1B2A41"/>
+                </a:solidFill>
+                <a:latin typeface="Calibri" pitchFamily="34" charset="0"/>
+                <a:ea typeface="Calibri" pitchFamily="34" charset="-122"/>
+                <a:cs typeface="Calibri" pitchFamily="34" charset="-120"/>
+              </a:rPr>
+              <a:t>Patil, Mao, Yan, Ji, Suresh, Stoica, Gonzalez. </a:t>
+            </a:r>
+            <a:pPr indent="0" marL="0">
+              <a:lnSpc>
+                <a:spcPct val="105000"/>
+              </a:lnSpc>
+              <a:spcAft>
+                <a:spcPts val="300"/>
+              </a:spcAft>
+              <a:buNone/>
+            </a:pPr>
+            <a:r>
+              <a:rPr lang="en-US" sz="950" dirty="0">
+                <a:solidFill>
+                  <a:srgbClr val="0F1B2D"/>
+                </a:solidFill>
+                <a:latin typeface="Calibri" pitchFamily="34" charset="0"/>
+                <a:ea typeface="Calibri" pitchFamily="34" charset="-122"/>
+                <a:cs typeface="Calibri" pitchFamily="34" charset="-120"/>
+              </a:rPr>
+              <a:t>The Berkeley Function Calling Leaderboard (BFCL): From tool use to agentic evaluation of LLMs. </a:t>
+            </a:r>
+            <a:pPr indent="0" marL="0">
+              <a:lnSpc>
+                <a:spcPct val="105000"/>
+              </a:lnSpc>
+              <a:spcAft>
+                <a:spcPts val="300"/>
+              </a:spcAft>
+              <a:buNone/>
+            </a:pPr>
+            <a:r>
+              <a:rPr lang="en-US" sz="950" i="1" dirty="0">
+                <a:solidFill>
+                  <a:srgbClr val="5B6B7F"/>
+                </a:solidFill>
+                <a:latin typeface="Calibri" pitchFamily="34" charset="0"/>
+                <a:ea typeface="Calibri" pitchFamily="34" charset="-122"/>
+                <a:cs typeface="Calibri" pitchFamily="34" charset="-120"/>
+              </a:rPr>
+              <a:t>ICML 2025</a:t>
+            </a:r>
+            <a:endParaRPr lang="en-US" sz="950" dirty="0"/>
+          </a:p>
+          <a:p>
+            <a:pPr indent="0" marL="0">
+              <a:lnSpc>
+                <a:spcPct val="105000"/>
+              </a:lnSpc>
+              <a:spcAft>
+                <a:spcPts val="300"/>
+              </a:spcAft>
+              <a:buNone/>
+            </a:pPr>
+            <a:r>
+              <a:rPr lang="en-US" sz="950" b="1" dirty="0">
+                <a:solidFill>
+                  <a:srgbClr val="0B7F8A"/>
+                </a:solidFill>
+                <a:latin typeface="Calibri" pitchFamily="34" charset="0"/>
+                <a:ea typeface="Calibri" pitchFamily="34" charset="-122"/>
+                <a:cs typeface="Calibri" pitchFamily="34" charset="-120"/>
+              </a:rPr>
+              <a:t>[4]  </a:t>
+            </a:r>
+            <a:pPr indent="0" marL="0">
+              <a:lnSpc>
+                <a:spcPct val="105000"/>
+              </a:lnSpc>
+              <a:spcAft>
+                <a:spcPts val="300"/>
+              </a:spcAft>
+              <a:buNone/>
+            </a:pPr>
+            <a:r>
+              <a:rPr lang="en-US" sz="950" dirty="0">
+                <a:solidFill>
+                  <a:srgbClr val="1B2A41"/>
+                </a:solidFill>
+                <a:latin typeface="Calibri" pitchFamily="34" charset="0"/>
+                <a:ea typeface="Calibri" pitchFamily="34" charset="-122"/>
+                <a:cs typeface="Calibri" pitchFamily="34" charset="-120"/>
+              </a:rPr>
+              <a:t>Wang, Zou, Lin, Sun, Liu, Zhang, Liu, Aw, Chen. </a:t>
+            </a:r>
+            <a:pPr indent="0" marL="0">
+              <a:lnSpc>
+                <a:spcPct val="105000"/>
+              </a:lnSpc>
+              <a:spcAft>
+                <a:spcPts val="300"/>
+              </a:spcAft>
+              <a:buNone/>
+            </a:pPr>
+            <a:r>
+              <a:rPr lang="en-US" sz="950" dirty="0">
+                <a:solidFill>
+                  <a:srgbClr val="0F1B2D"/>
+                </a:solidFill>
+                <a:latin typeface="Calibri" pitchFamily="34" charset="0"/>
+                <a:ea typeface="Calibri" pitchFamily="34" charset="-122"/>
+                <a:cs typeface="Calibri" pitchFamily="34" charset="-120"/>
+              </a:rPr>
+              <a:t>AudioBench: A universal benchmark for audio large language models. </a:t>
+            </a:r>
+            <a:pPr indent="0" marL="0">
+              <a:lnSpc>
+                <a:spcPct val="105000"/>
+              </a:lnSpc>
+              <a:spcAft>
+                <a:spcPts val="300"/>
+              </a:spcAft>
+              <a:buNone/>
+            </a:pPr>
+            <a:r>
+              <a:rPr lang="en-US" sz="950" i="1" dirty="0">
+                <a:solidFill>
+                  <a:srgbClr val="5B6B7F"/>
+                </a:solidFill>
+                <a:latin typeface="Calibri" pitchFamily="34" charset="0"/>
+                <a:ea typeface="Calibri" pitchFamily="34" charset="-122"/>
+                <a:cs typeface="Calibri" pitchFamily="34" charset="-120"/>
+              </a:rPr>
+              <a:t>NAACL 2025</a:t>
+            </a:r>
+            <a:endParaRPr lang="en-US" sz="950" dirty="0"/>
+          </a:p>
+          <a:p>
+            <a:pPr indent="0" marL="0">
+              <a:lnSpc>
+                <a:spcPct val="105000"/>
+              </a:lnSpc>
+              <a:spcAft>
+                <a:spcPts val="300"/>
+              </a:spcAft>
+              <a:buNone/>
+            </a:pPr>
+            <a:r>
+              <a:rPr lang="en-US" sz="950" b="1" dirty="0">
+                <a:solidFill>
+                  <a:srgbClr val="0B7F8A"/>
+                </a:solidFill>
+                <a:latin typeface="Calibri" pitchFamily="34" charset="0"/>
+                <a:ea typeface="Calibri" pitchFamily="34" charset="-122"/>
+                <a:cs typeface="Calibri" pitchFamily="34" charset="-120"/>
+              </a:rPr>
+              <a:t>[5]  </a:t>
+            </a:r>
+            <a:pPr indent="0" marL="0">
+              <a:lnSpc>
+                <a:spcPct val="105000"/>
+              </a:lnSpc>
+              <a:spcAft>
+                <a:spcPts val="300"/>
+              </a:spcAft>
+              <a:buNone/>
+            </a:pPr>
+            <a:r>
+              <a:rPr lang="en-US" sz="950" dirty="0">
+                <a:solidFill>
+                  <a:srgbClr val="1B2A41"/>
+                </a:solidFill>
+                <a:latin typeface="Calibri" pitchFamily="34" charset="0"/>
+                <a:ea typeface="Calibri" pitchFamily="34" charset="-122"/>
+                <a:cs typeface="Calibri" pitchFamily="34" charset="-120"/>
+              </a:rPr>
+              <a:t>Jain, Shukla, Rajeev, Kulkarni, Khatri, Agarwal. </a:t>
+            </a:r>
+            <a:pPr indent="0" marL="0">
+              <a:lnSpc>
+                <a:spcPct val="105000"/>
+              </a:lnSpc>
+              <a:spcAft>
+                <a:spcPts val="300"/>
+              </a:spcAft>
+              <a:buNone/>
+            </a:pPr>
+            <a:r>
+              <a:rPr lang="en-US" sz="950" dirty="0">
+                <a:solidFill>
+                  <a:srgbClr val="0F1B2D"/>
+                </a:solidFill>
+                <a:latin typeface="Calibri" pitchFamily="34" charset="0"/>
+                <a:ea typeface="Calibri" pitchFamily="34" charset="-122"/>
+                <a:cs typeface="Calibri" pitchFamily="34" charset="-120"/>
+              </a:rPr>
+              <a:t>VoiceAgentBench: Are voice assistants ready for agentic tasks? </a:t>
+            </a:r>
+            <a:pPr indent="0" marL="0">
+              <a:lnSpc>
+                <a:spcPct val="105000"/>
+              </a:lnSpc>
+              <a:spcAft>
+                <a:spcPts val="300"/>
+              </a:spcAft>
+              <a:buNone/>
+            </a:pPr>
+            <a:r>
+              <a:rPr lang="en-US" sz="950" i="1" dirty="0">
+                <a:solidFill>
+                  <a:srgbClr val="5B6B7F"/>
+                </a:solidFill>
+                <a:latin typeface="Calibri" pitchFamily="34" charset="0"/>
+                <a:ea typeface="Calibri" pitchFamily="34" charset="-122"/>
+                <a:cs typeface="Calibri" pitchFamily="34" charset="-120"/>
+              </a:rPr>
+              <a:t>arXiv:2510.07978, 2025</a:t>
+            </a:r>
+            <a:endParaRPr lang="en-US" sz="950" dirty="0"/>
+          </a:p>
+          <a:p>
+            <a:pPr indent="0" marL="0">
+              <a:lnSpc>
+                <a:spcPct val="105000"/>
+              </a:lnSpc>
+              <a:spcAft>
+                <a:spcPts val="300"/>
+              </a:spcAft>
+              <a:buNone/>
+            </a:pPr>
+            <a:r>
+              <a:rPr lang="en-US" sz="950" b="1" dirty="0">
+                <a:solidFill>
+                  <a:srgbClr val="0B7F8A"/>
+                </a:solidFill>
+                <a:latin typeface="Calibri" pitchFamily="34" charset="0"/>
+                <a:ea typeface="Calibri" pitchFamily="34" charset="-122"/>
+                <a:cs typeface="Calibri" pitchFamily="34" charset="-120"/>
+              </a:rPr>
+              <a:t>[6]  </a:t>
+            </a:r>
+            <a:pPr indent="0" marL="0">
+              <a:lnSpc>
+                <a:spcPct val="105000"/>
+              </a:lnSpc>
+              <a:spcAft>
+                <a:spcPts val="300"/>
+              </a:spcAft>
+              <a:buNone/>
+            </a:pPr>
+            <a:r>
+              <a:rPr lang="en-US" sz="950" dirty="0">
+                <a:solidFill>
+                  <a:srgbClr val="1B2A41"/>
+                </a:solidFill>
+                <a:latin typeface="Calibri" pitchFamily="34" charset="0"/>
+                <a:ea typeface="Calibri" pitchFamily="34" charset="-122"/>
+                <a:cs typeface="Calibri" pitchFamily="34" charset="-120"/>
+              </a:rPr>
+              <a:t>Hemphill, Godfrey, Doddington. </a:t>
+            </a:r>
+            <a:pPr indent="0" marL="0">
+              <a:lnSpc>
+                <a:spcPct val="105000"/>
+              </a:lnSpc>
+              <a:spcAft>
+                <a:spcPts val="300"/>
+              </a:spcAft>
+              <a:buNone/>
+            </a:pPr>
+            <a:r>
+              <a:rPr lang="en-US" sz="950" dirty="0">
+                <a:solidFill>
+                  <a:srgbClr val="0F1B2D"/>
+                </a:solidFill>
+                <a:latin typeface="Calibri" pitchFamily="34" charset="0"/>
+                <a:ea typeface="Calibri" pitchFamily="34" charset="-122"/>
+                <a:cs typeface="Calibri" pitchFamily="34" charset="-120"/>
+              </a:rPr>
+              <a:t>The ATIS spoken language systems pilot corpus. </a:t>
+            </a:r>
+            <a:pPr indent="0" marL="0">
+              <a:lnSpc>
+                <a:spcPct val="105000"/>
+              </a:lnSpc>
+              <a:spcAft>
+                <a:spcPts val="300"/>
+              </a:spcAft>
+              <a:buNone/>
+            </a:pPr>
+            <a:r>
+              <a:rPr lang="en-US" sz="950" i="1" dirty="0">
+                <a:solidFill>
+                  <a:srgbClr val="5B6B7F"/>
+                </a:solidFill>
+                <a:latin typeface="Calibri" pitchFamily="34" charset="0"/>
+                <a:ea typeface="Calibri" pitchFamily="34" charset="-122"/>
+                <a:cs typeface="Calibri" pitchFamily="34" charset="-120"/>
+              </a:rPr>
+              <a:t>Workshop on Speech and Natural Language, 1990</a:t>
+            </a:r>
+            <a:endParaRPr lang="en-US" sz="950" dirty="0"/>
+          </a:p>
+          <a:p>
+            <a:pPr indent="0" marL="0">
+              <a:lnSpc>
+                <a:spcPct val="105000"/>
+              </a:lnSpc>
+              <a:spcAft>
+                <a:spcPts val="300"/>
+              </a:spcAft>
+              <a:buNone/>
+            </a:pPr>
+            <a:r>
+              <a:rPr lang="en-US" sz="950" b="1" dirty="0">
+                <a:solidFill>
+                  <a:srgbClr val="0B7F8A"/>
+                </a:solidFill>
+                <a:latin typeface="Calibri" pitchFamily="34" charset="0"/>
+                <a:ea typeface="Calibri" pitchFamily="34" charset="-122"/>
+                <a:cs typeface="Calibri" pitchFamily="34" charset="-120"/>
+              </a:rPr>
+              <a:t>[7]  </a:t>
+            </a:r>
+            <a:pPr indent="0" marL="0">
+              <a:lnSpc>
+                <a:spcPct val="105000"/>
+              </a:lnSpc>
+              <a:spcAft>
+                <a:spcPts val="300"/>
+              </a:spcAft>
+              <a:buNone/>
+            </a:pPr>
+            <a:r>
+              <a:rPr lang="en-US" sz="950" dirty="0">
+                <a:solidFill>
+                  <a:srgbClr val="1B2A41"/>
+                </a:solidFill>
+                <a:latin typeface="Calibri" pitchFamily="34" charset="0"/>
+                <a:ea typeface="Calibri" pitchFamily="34" charset="-122"/>
+                <a:cs typeface="Calibri" pitchFamily="34" charset="-120"/>
+              </a:rPr>
+              <a:t>Bastianelli et al. </a:t>
+            </a:r>
+            <a:pPr indent="0" marL="0">
+              <a:lnSpc>
+                <a:spcPct val="105000"/>
+              </a:lnSpc>
+              <a:spcAft>
+                <a:spcPts val="300"/>
+              </a:spcAft>
+              <a:buNone/>
+            </a:pPr>
+            <a:r>
+              <a:rPr lang="en-US" sz="950" dirty="0">
+                <a:solidFill>
+                  <a:srgbClr val="0F1B2D"/>
+                </a:solidFill>
+                <a:latin typeface="Calibri" pitchFamily="34" charset="0"/>
+                <a:ea typeface="Calibri" pitchFamily="34" charset="-122"/>
+                <a:cs typeface="Calibri" pitchFamily="34" charset="-120"/>
+              </a:rPr>
+              <a:t>SLURP: A spoken language understanding resource package. </a:t>
+            </a:r>
+            <a:pPr indent="0" marL="0">
+              <a:lnSpc>
+                <a:spcPct val="105000"/>
+              </a:lnSpc>
+              <a:spcAft>
+                <a:spcPts val="300"/>
+              </a:spcAft>
+              <a:buNone/>
+            </a:pPr>
+            <a:r>
+              <a:rPr lang="en-US" sz="950" i="1" dirty="0">
+                <a:solidFill>
+                  <a:srgbClr val="5B6B7F"/>
+                </a:solidFill>
+                <a:latin typeface="Calibri" pitchFamily="34" charset="0"/>
+                <a:ea typeface="Calibri" pitchFamily="34" charset="-122"/>
+                <a:cs typeface="Calibri" pitchFamily="34" charset="-120"/>
+              </a:rPr>
+              <a:t>EMNLP 2020</a:t>
+            </a:r>
+            <a:endParaRPr lang="en-US" sz="950" dirty="0"/>
+          </a:p>
+          <a:p>
+            <a:pPr indent="0" marL="0">
+              <a:lnSpc>
+                <a:spcPct val="105000"/>
+              </a:lnSpc>
+              <a:spcAft>
+                <a:spcPts val="300"/>
+              </a:spcAft>
+              <a:buNone/>
+            </a:pPr>
+            <a:r>
+              <a:rPr lang="en-US" sz="950" b="1" dirty="0">
+                <a:solidFill>
+                  <a:srgbClr val="0B7F8A"/>
+                </a:solidFill>
+                <a:latin typeface="Calibri" pitchFamily="34" charset="0"/>
+                <a:ea typeface="Calibri" pitchFamily="34" charset="-122"/>
+                <a:cs typeface="Calibri" pitchFamily="34" charset="-120"/>
+              </a:rPr>
+              <a:t>[8]  </a:t>
+            </a:r>
+            <a:pPr indent="0" marL="0">
+              <a:lnSpc>
+                <a:spcPct val="105000"/>
+              </a:lnSpc>
+              <a:spcAft>
+                <a:spcPts val="300"/>
+              </a:spcAft>
+              <a:buNone/>
+            </a:pPr>
+            <a:r>
+              <a:rPr lang="en-US" sz="950" dirty="0">
+                <a:solidFill>
+                  <a:srgbClr val="1B2A41"/>
+                </a:solidFill>
+                <a:latin typeface="Calibri" pitchFamily="34" charset="0"/>
+                <a:ea typeface="Calibri" pitchFamily="34" charset="-122"/>
+                <a:cs typeface="Calibri" pitchFamily="34" charset="-120"/>
+              </a:rPr>
+              <a:t>Tomasello, Shrivastava, Lazar, et al. </a:t>
+            </a:r>
+            <a:pPr indent="0" marL="0">
+              <a:lnSpc>
+                <a:spcPct val="105000"/>
+              </a:lnSpc>
+              <a:spcAft>
+                <a:spcPts val="300"/>
+              </a:spcAft>
+              <a:buNone/>
+            </a:pPr>
+            <a:r>
+              <a:rPr lang="en-US" sz="950" dirty="0">
+                <a:solidFill>
+                  <a:srgbClr val="0F1B2D"/>
+                </a:solidFill>
+                <a:latin typeface="Calibri" pitchFamily="34" charset="0"/>
+                <a:ea typeface="Calibri" pitchFamily="34" charset="-122"/>
+                <a:cs typeface="Calibri" pitchFamily="34" charset="-120"/>
+              </a:rPr>
+              <a:t>STOP: A dataset for spoken task oriented semantic parsing. </a:t>
+            </a:r>
+            <a:pPr indent="0" marL="0">
+              <a:lnSpc>
+                <a:spcPct val="105000"/>
+              </a:lnSpc>
+              <a:spcAft>
+                <a:spcPts val="300"/>
+              </a:spcAft>
+              <a:buNone/>
+            </a:pPr>
+            <a:r>
+              <a:rPr lang="en-US" sz="950" i="1" dirty="0">
+                <a:solidFill>
+                  <a:srgbClr val="5B6B7F"/>
+                </a:solidFill>
+                <a:latin typeface="Calibri" pitchFamily="34" charset="0"/>
+                <a:ea typeface="Calibri" pitchFamily="34" charset="-122"/>
+                <a:cs typeface="Calibri" pitchFamily="34" charset="-120"/>
+              </a:rPr>
+              <a:t>arXiv:2207.10643, 2022</a:t>
+            </a:r>
+            <a:endParaRPr lang="en-US" sz="950" dirty="0"/>
+          </a:p>
+          <a:p>
+            <a:pPr indent="0" marL="0">
+              <a:lnSpc>
+                <a:spcPct val="105000"/>
+              </a:lnSpc>
+              <a:spcAft>
+                <a:spcPts val="300"/>
+              </a:spcAft>
+              <a:buNone/>
+            </a:pPr>
+            <a:r>
+              <a:rPr lang="en-US" sz="950" b="1" dirty="0">
+                <a:solidFill>
+                  <a:srgbClr val="0B7F8A"/>
+                </a:solidFill>
+                <a:latin typeface="Calibri" pitchFamily="34" charset="0"/>
+                <a:ea typeface="Calibri" pitchFamily="34" charset="-122"/>
+                <a:cs typeface="Calibri" pitchFamily="34" charset="-120"/>
+              </a:rPr>
+              <a:t>[9]  </a:t>
+            </a:r>
+            <a:pPr indent="0" marL="0">
+              <a:lnSpc>
+                <a:spcPct val="105000"/>
+              </a:lnSpc>
+              <a:spcAft>
+                <a:spcPts val="300"/>
+              </a:spcAft>
+              <a:buNone/>
+            </a:pPr>
+            <a:r>
+              <a:rPr lang="en-US" sz="950" dirty="0">
+                <a:solidFill>
+                  <a:srgbClr val="1B2A41"/>
+                </a:solidFill>
+                <a:latin typeface="Calibri" pitchFamily="34" charset="0"/>
+                <a:ea typeface="Calibri" pitchFamily="34" charset="-122"/>
+                <a:cs typeface="Calibri" pitchFamily="34" charset="-120"/>
+              </a:rPr>
+              <a:t>Peng, Cai, Liu, et al. </a:t>
+            </a:r>
+            <a:pPr indent="0" marL="0">
+              <a:lnSpc>
+                <a:spcPct val="105000"/>
+              </a:lnSpc>
+              <a:spcAft>
+                <a:spcPts val="300"/>
+              </a:spcAft>
+              <a:buNone/>
+            </a:pPr>
+            <a:r>
+              <a:rPr lang="en-US" sz="950" dirty="0">
+                <a:solidFill>
+                  <a:srgbClr val="0F1B2D"/>
+                </a:solidFill>
+                <a:latin typeface="Calibri" pitchFamily="34" charset="0"/>
+                <a:ea typeface="Calibri" pitchFamily="34" charset="-122"/>
+                <a:cs typeface="Calibri" pitchFamily="34" charset="-120"/>
+              </a:rPr>
+              <a:t>MAC-SLU: Multi-intent automotive cabin spoken language understanding benchmark. </a:t>
+            </a:r>
+            <a:pPr indent="0" marL="0">
+              <a:lnSpc>
+                <a:spcPct val="105000"/>
+              </a:lnSpc>
+              <a:spcAft>
+                <a:spcPts val="300"/>
+              </a:spcAft>
+              <a:buNone/>
+            </a:pPr>
+            <a:r>
+              <a:rPr lang="en-US" sz="950" i="1" dirty="0">
+                <a:solidFill>
+                  <a:srgbClr val="5B6B7F"/>
+                </a:solidFill>
+                <a:latin typeface="Calibri" pitchFamily="34" charset="0"/>
+                <a:ea typeface="Calibri" pitchFamily="34" charset="-122"/>
+                <a:cs typeface="Calibri" pitchFamily="34" charset="-120"/>
+              </a:rPr>
+              <a:t>arXiv:2512.01603, 2025</a:t>
+            </a:r>
+            <a:endParaRPr lang="en-US" sz="950" dirty="0"/>
+          </a:p>
+          <a:p>
+            <a:pPr indent="0" marL="0">
+              <a:lnSpc>
+                <a:spcPct val="105000"/>
+              </a:lnSpc>
+              <a:spcAft>
+                <a:spcPts val="300"/>
+              </a:spcAft>
+              <a:buNone/>
+            </a:pPr>
+            <a:r>
+              <a:rPr lang="en-US" sz="950" b="1" dirty="0">
+                <a:solidFill>
+                  <a:srgbClr val="0B7F8A"/>
+                </a:solidFill>
+                <a:latin typeface="Calibri" pitchFamily="34" charset="0"/>
+                <a:ea typeface="Calibri" pitchFamily="34" charset="-122"/>
+                <a:cs typeface="Calibri" pitchFamily="34" charset="-120"/>
+              </a:rPr>
+              <a:t>[10]  </a:t>
+            </a:r>
+            <a:pPr indent="0" marL="0">
+              <a:lnSpc>
+                <a:spcPct val="105000"/>
+              </a:lnSpc>
+              <a:spcAft>
+                <a:spcPts val="300"/>
+              </a:spcAft>
+              <a:buNone/>
+            </a:pPr>
+            <a:r>
+              <a:rPr lang="en-US" sz="950" dirty="0">
+                <a:solidFill>
+                  <a:srgbClr val="1B2A41"/>
+                </a:solidFill>
+                <a:latin typeface="Calibri" pitchFamily="34" charset="0"/>
+                <a:ea typeface="Calibri" pitchFamily="34" charset="-122"/>
+                <a:cs typeface="Calibri" pitchFamily="34" charset="-120"/>
+              </a:rPr>
+              <a:t>Mao, Ginart, Emmons. </a:t>
+            </a:r>
+            <a:pPr indent="0" marL="0">
+              <a:lnSpc>
+                <a:spcPct val="105000"/>
+              </a:lnSpc>
+              <a:spcAft>
+                <a:spcPts val="300"/>
+              </a:spcAft>
+              <a:buNone/>
+            </a:pPr>
+            <a:r>
+              <a:rPr lang="en-US" sz="950" dirty="0">
+                <a:solidFill>
+                  <a:srgbClr val="0F1B2D"/>
+                </a:solidFill>
+                <a:latin typeface="Calibri" pitchFamily="34" charset="0"/>
+                <a:ea typeface="Calibri" pitchFamily="34" charset="-122"/>
+                <a:cs typeface="Calibri" pitchFamily="34" charset="-120"/>
+              </a:rPr>
+              <a:t>BFCL Audio: A benchmark for audio-native function calling. </a:t>
+            </a:r>
+            <a:pPr indent="0" marL="0">
+              <a:lnSpc>
+                <a:spcPct val="105000"/>
+              </a:lnSpc>
+              <a:spcAft>
+                <a:spcPts val="300"/>
+              </a:spcAft>
+              <a:buNone/>
+            </a:pPr>
+            <a:r>
+              <a:rPr lang="en-US" sz="950" i="1" dirty="0">
+                <a:solidFill>
+                  <a:srgbClr val="5B6B7F"/>
+                </a:solidFill>
+                <a:latin typeface="Calibri" pitchFamily="34" charset="0"/>
+                <a:ea typeface="Calibri" pitchFamily="34" charset="-122"/>
+                <a:cs typeface="Calibri" pitchFamily="34" charset="-120"/>
+              </a:rPr>
+              <a:t>Salesforce AI Research blog, 2025</a:t>
+            </a:r>
+            <a:endParaRPr lang="en-US" sz="950" dirty="0"/>
+          </a:p>
+          <a:p>
+            <a:pPr indent="0" marL="0">
+              <a:lnSpc>
+                <a:spcPct val="105000"/>
+              </a:lnSpc>
+              <a:spcAft>
+                <a:spcPts val="300"/>
+              </a:spcAft>
+              <a:buNone/>
+            </a:pPr>
+            <a:r>
+              <a:rPr lang="en-US" sz="950" b="1" dirty="0">
+                <a:solidFill>
+                  <a:srgbClr val="0B7F8A"/>
+                </a:solidFill>
+                <a:latin typeface="Calibri" pitchFamily="34" charset="0"/>
+                <a:ea typeface="Calibri" pitchFamily="34" charset="-122"/>
+                <a:cs typeface="Calibri" pitchFamily="34" charset="-120"/>
+              </a:rPr>
+              <a:t>[11]  </a:t>
+            </a:r>
+            <a:pPr indent="0" marL="0">
+              <a:lnSpc>
+                <a:spcPct val="105000"/>
+              </a:lnSpc>
+              <a:spcAft>
+                <a:spcPts val="300"/>
+              </a:spcAft>
+              <a:buNone/>
+            </a:pPr>
+            <a:r>
+              <a:rPr lang="en-US" sz="950" dirty="0">
+                <a:solidFill>
+                  <a:srgbClr val="1B2A41"/>
+                </a:solidFill>
+                <a:latin typeface="Calibri" pitchFamily="34" charset="0"/>
+                <a:ea typeface="Calibri" pitchFamily="34" charset="-122"/>
+                <a:cs typeface="Calibri" pitchFamily="34" charset="-120"/>
+              </a:rPr>
+              <a:t>Mao, Patil, Gonzalez. </a:t>
+            </a:r>
+            <a:pPr indent="0" marL="0">
+              <a:lnSpc>
+                <a:spcPct val="105000"/>
+              </a:lnSpc>
+              <a:spcAft>
+                <a:spcPts val="300"/>
+              </a:spcAft>
+              <a:buNone/>
+            </a:pPr>
+            <a:r>
+              <a:rPr lang="en-US" sz="950" dirty="0">
+                <a:solidFill>
+                  <a:srgbClr val="0F1B2D"/>
+                </a:solidFill>
+                <a:latin typeface="Calibri" pitchFamily="34" charset="0"/>
+                <a:ea typeface="Calibri" pitchFamily="34" charset="-122"/>
+                <a:cs typeface="Calibri" pitchFamily="34" charset="-120"/>
+              </a:rPr>
+              <a:t>MFCL: A multi-modal function calling evaluation for large language models. </a:t>
+            </a:r>
+            <a:pPr indent="0" marL="0">
+              <a:lnSpc>
+                <a:spcPct val="105000"/>
+              </a:lnSpc>
+              <a:spcAft>
+                <a:spcPts val="300"/>
+              </a:spcAft>
+              <a:buNone/>
+            </a:pPr>
+            <a:r>
+              <a:rPr lang="en-US" sz="950" i="1" dirty="0">
+                <a:solidFill>
+                  <a:srgbClr val="5B6B7F"/>
+                </a:solidFill>
+                <a:latin typeface="Calibri" pitchFamily="34" charset="0"/>
+                <a:ea typeface="Calibri" pitchFamily="34" charset="-122"/>
+                <a:cs typeface="Calibri" pitchFamily="34" charset="-120"/>
+              </a:rPr>
+              <a:t>OpenReview, 2025</a:t>
+            </a:r>
+            <a:endParaRPr lang="en-US" sz="950" dirty="0"/>
+          </a:p>
+          <a:p>
+            <a:pPr indent="0" marL="0">
+              <a:lnSpc>
+                <a:spcPct val="105000"/>
+              </a:lnSpc>
+              <a:spcAft>
+                <a:spcPts val="300"/>
+              </a:spcAft>
+              <a:buNone/>
+            </a:pPr>
+            <a:r>
+              <a:rPr lang="en-US" sz="950" b="1" dirty="0">
+                <a:solidFill>
+                  <a:srgbClr val="0B7F8A"/>
+                </a:solidFill>
+                <a:latin typeface="Calibri" pitchFamily="34" charset="0"/>
+                <a:ea typeface="Calibri" pitchFamily="34" charset="-122"/>
+                <a:cs typeface="Calibri" pitchFamily="34" charset="-120"/>
+              </a:rPr>
+              <a:t>[12]  </a:t>
+            </a:r>
+            <a:pPr indent="0" marL="0">
+              <a:lnSpc>
+                <a:spcPct val="105000"/>
+              </a:lnSpc>
+              <a:spcAft>
+                <a:spcPts val="300"/>
+              </a:spcAft>
+              <a:buNone/>
+            </a:pPr>
+            <a:r>
+              <a:rPr lang="en-US" sz="950" dirty="0">
+                <a:solidFill>
+                  <a:srgbClr val="1B2A41"/>
+                </a:solidFill>
+                <a:latin typeface="Calibri" pitchFamily="34" charset="0"/>
+                <a:ea typeface="Calibri" pitchFamily="34" charset="-122"/>
+                <a:cs typeface="Calibri" pitchFamily="34" charset="-120"/>
+              </a:rPr>
+              <a:t>Coucke, Saade, Ball, et al. </a:t>
+            </a:r>
+            <a:pPr indent="0" marL="0">
+              <a:lnSpc>
+                <a:spcPct val="105000"/>
+              </a:lnSpc>
+              <a:spcAft>
+                <a:spcPts val="300"/>
+              </a:spcAft>
+              <a:buNone/>
+            </a:pPr>
+            <a:r>
+              <a:rPr lang="en-US" sz="950" dirty="0">
+                <a:solidFill>
+                  <a:srgbClr val="0F1B2D"/>
+                </a:solidFill>
+                <a:latin typeface="Calibri" pitchFamily="34" charset="0"/>
+                <a:ea typeface="Calibri" pitchFamily="34" charset="-122"/>
+                <a:cs typeface="Calibri" pitchFamily="34" charset="-120"/>
+              </a:rPr>
+              <a:t>Snips voice platform: An embedded SLU system for private-by-design voice interfaces. </a:t>
+            </a:r>
+            <a:pPr indent="0" marL="0">
+              <a:lnSpc>
+                <a:spcPct val="105000"/>
+              </a:lnSpc>
+              <a:spcAft>
+                <a:spcPts val="300"/>
+              </a:spcAft>
+              <a:buNone/>
+            </a:pPr>
+            <a:r>
+              <a:rPr lang="en-US" sz="950" i="1" dirty="0">
+                <a:solidFill>
+                  <a:srgbClr val="5B6B7F"/>
+                </a:solidFill>
+                <a:latin typeface="Calibri" pitchFamily="34" charset="0"/>
+                <a:ea typeface="Calibri" pitchFamily="34" charset="-122"/>
+                <a:cs typeface="Calibri" pitchFamily="34" charset="-120"/>
+              </a:rPr>
+              <a:t>EMNLP 2018</a:t>
+            </a:r>
+            <a:endParaRPr lang="en-US" sz="950" dirty="0"/>
+          </a:p>
+          <a:p>
+            <a:pPr indent="0" marL="0">
+              <a:lnSpc>
+                <a:spcPct val="105000"/>
+              </a:lnSpc>
+              <a:spcAft>
+                <a:spcPts val="300"/>
+              </a:spcAft>
+              <a:buNone/>
+            </a:pPr>
+            <a:r>
+              <a:rPr lang="en-US" sz="950" b="1" dirty="0">
+                <a:solidFill>
+                  <a:srgbClr val="0B7F8A"/>
+                </a:solidFill>
+                <a:latin typeface="Calibri" pitchFamily="34" charset="0"/>
+                <a:ea typeface="Calibri" pitchFamily="34" charset="-122"/>
+                <a:cs typeface="Calibri" pitchFamily="34" charset="-120"/>
+              </a:rPr>
+              <a:t>[13]  </a:t>
+            </a:r>
+            <a:pPr indent="0" marL="0">
+              <a:lnSpc>
+                <a:spcPct val="105000"/>
+              </a:lnSpc>
+              <a:spcAft>
+                <a:spcPts val="300"/>
+              </a:spcAft>
+              <a:buNone/>
+            </a:pPr>
+            <a:r>
+              <a:rPr lang="en-US" sz="950" dirty="0">
+                <a:solidFill>
+                  <a:srgbClr val="1B2A41"/>
+                </a:solidFill>
+                <a:latin typeface="Calibri" pitchFamily="34" charset="0"/>
+                <a:ea typeface="Calibri" pitchFamily="34" charset="-122"/>
+                <a:cs typeface="Calibri" pitchFamily="34" charset="-120"/>
+              </a:rPr>
+              <a:t>Nguyen, Hoang, Tu, Ngo. </a:t>
+            </a:r>
+            <a:pPr indent="0" marL="0">
+              <a:lnSpc>
+                <a:spcPct val="105000"/>
+              </a:lnSpc>
+              <a:spcAft>
+                <a:spcPts val="300"/>
+              </a:spcAft>
+              <a:buNone/>
+            </a:pPr>
+            <a:r>
+              <a:rPr lang="en-US" sz="950" dirty="0">
+                <a:solidFill>
+                  <a:srgbClr val="0F1B2D"/>
+                </a:solidFill>
+                <a:latin typeface="Calibri" pitchFamily="34" charset="0"/>
+                <a:ea typeface="Calibri" pitchFamily="34" charset="-122"/>
+                <a:cs typeface="Calibri" pitchFamily="34" charset="-120"/>
+              </a:rPr>
+              <a:t>Joint multiple intent detection and slot filling with supervised contrastive learning and self-distillation. </a:t>
+            </a:r>
+            <a:pPr indent="0" marL="0">
+              <a:lnSpc>
+                <a:spcPct val="105000"/>
+              </a:lnSpc>
+              <a:spcAft>
+                <a:spcPts val="300"/>
+              </a:spcAft>
+              <a:buNone/>
+            </a:pPr>
+            <a:r>
+              <a:rPr lang="en-US" sz="950" i="1" dirty="0">
+                <a:solidFill>
+                  <a:srgbClr val="5B6B7F"/>
+                </a:solidFill>
+                <a:latin typeface="Calibri" pitchFamily="34" charset="0"/>
+                <a:ea typeface="Calibri" pitchFamily="34" charset="-122"/>
+                <a:cs typeface="Calibri" pitchFamily="34" charset="-120"/>
+              </a:rPr>
+              <a:t>arXiv:2308.14654, 2023</a:t>
+            </a:r>
+            <a:endParaRPr lang="en-US" sz="950" dirty="0"/>
+          </a:p>
+          <a:p>
+            <a:pPr indent="0" marL="0">
+              <a:lnSpc>
+                <a:spcPct val="105000"/>
+              </a:lnSpc>
+              <a:spcAft>
+                <a:spcPts val="300"/>
+              </a:spcAft>
+              <a:buNone/>
+            </a:pPr>
+            <a:r>
+              <a:rPr lang="en-US" sz="950" b="1" dirty="0">
+                <a:solidFill>
+                  <a:srgbClr val="0B7F8A"/>
+                </a:solidFill>
+                <a:latin typeface="Calibri" pitchFamily="34" charset="0"/>
+                <a:ea typeface="Calibri" pitchFamily="34" charset="-122"/>
+                <a:cs typeface="Calibri" pitchFamily="34" charset="-120"/>
+              </a:rPr>
+              <a:t>[14]  </a:t>
+            </a:r>
+            <a:pPr indent="0" marL="0">
+              <a:lnSpc>
+                <a:spcPct val="105000"/>
+              </a:lnSpc>
+              <a:spcAft>
+                <a:spcPts val="300"/>
+              </a:spcAft>
+              <a:buNone/>
+            </a:pPr>
+            <a:r>
+              <a:rPr lang="en-US" sz="950" dirty="0">
+                <a:solidFill>
+                  <a:srgbClr val="1B2A41"/>
+                </a:solidFill>
+                <a:latin typeface="Calibri" pitchFamily="34" charset="0"/>
+                <a:ea typeface="Calibri" pitchFamily="34" charset="-122"/>
+                <a:cs typeface="Calibri" pitchFamily="34" charset="-120"/>
+              </a:rPr>
+              <a:t>Qin, Xu, Che, Liu. </a:t>
+            </a:r>
+            <a:pPr indent="0" marL="0">
+              <a:lnSpc>
+                <a:spcPct val="105000"/>
+              </a:lnSpc>
+              <a:spcAft>
+                <a:spcPts val="300"/>
+              </a:spcAft>
+              <a:buNone/>
+            </a:pPr>
+            <a:r>
+              <a:rPr lang="en-US" sz="950" dirty="0">
+                <a:solidFill>
+                  <a:srgbClr val="0F1B2D"/>
+                </a:solidFill>
+                <a:latin typeface="Calibri" pitchFamily="34" charset="0"/>
+                <a:ea typeface="Calibri" pitchFamily="34" charset="-122"/>
+                <a:cs typeface="Calibri" pitchFamily="34" charset="-120"/>
+              </a:rPr>
+              <a:t>AGIF: An adaptive graph-interactive framework for joint multiple intent detection and slot filling. </a:t>
+            </a:r>
+            <a:pPr indent="0" marL="0">
+              <a:lnSpc>
+                <a:spcPct val="105000"/>
+              </a:lnSpc>
+              <a:spcAft>
+                <a:spcPts val="300"/>
+              </a:spcAft>
+              <a:buNone/>
+            </a:pPr>
+            <a:r>
+              <a:rPr lang="en-US" sz="950" i="1" dirty="0">
+                <a:solidFill>
+                  <a:srgbClr val="5B6B7F"/>
+                </a:solidFill>
+                <a:latin typeface="Calibri" pitchFamily="34" charset="0"/>
+                <a:ea typeface="Calibri" pitchFamily="34" charset="-122"/>
+                <a:cs typeface="Calibri" pitchFamily="34" charset="-120"/>
+              </a:rPr>
+              <a:t>Findings of EMNLP 2020</a:t>
+            </a:r>
+            <a:endParaRPr lang="en-US" sz="950" dirty="0"/>
+          </a:p>
+        </p:txBody>
+      </p:sp>
+      <p:sp>
+        <p:nvSpPr>
+          <p:cNvPr id="15" name="Text 12"/>
+          <p:cNvSpPr txBox="1"/>
+          <p:nvPr/>
+        </p:nvSpPr>
+        <p:spPr>
+          <a:xfrm>
+            <a:off x="6172200" y="1463040"/>
+            <a:ext cx="5468112" cy="4892040"/>
+          </a:xfrm>
+          <a:prstGeom prst="rect">
+            <a:avLst/>
+          </a:prstGeom>
+          <a:noFill/>
+          <a:ln/>
+        </p:spPr>
+        <p:txBody>
+          <a:bodyPr wrap="square" lIns="0" tIns="0" rIns="0" bIns="0" rtlCol="0" anchor="t"/>
+          <a:lstStyle/>
+          <a:p>
+            <a:pPr indent="0" marL="0">
+              <a:lnSpc>
+                <a:spcPct val="105000"/>
+              </a:lnSpc>
+              <a:spcAft>
+                <a:spcPts val="300"/>
+              </a:spcAft>
+              <a:buNone/>
+            </a:pPr>
+            <a:r>
+              <a:rPr lang="en-US" sz="950" b="1" dirty="0">
+                <a:solidFill>
+                  <a:srgbClr val="0B7F8A"/>
+                </a:solidFill>
+                <a:latin typeface="Calibri" pitchFamily="34" charset="0"/>
+                <a:ea typeface="Calibri" pitchFamily="34" charset="-122"/>
+                <a:cs typeface="Calibri" pitchFamily="34" charset="-120"/>
+              </a:rPr>
+              <a:t>[15]  </a:t>
+            </a:r>
+            <a:pPr indent="0" marL="0">
+              <a:lnSpc>
+                <a:spcPct val="105000"/>
+              </a:lnSpc>
+              <a:spcAft>
+                <a:spcPts val="300"/>
+              </a:spcAft>
+              <a:buNone/>
+            </a:pPr>
+            <a:r>
+              <a:rPr lang="en-US" sz="950" dirty="0">
+                <a:solidFill>
+                  <a:srgbClr val="1B2A41"/>
+                </a:solidFill>
+                <a:latin typeface="Calibri" pitchFamily="34" charset="0"/>
+                <a:ea typeface="Calibri" pitchFamily="34" charset="-122"/>
+                <a:cs typeface="Calibri" pitchFamily="34" charset="-120"/>
+              </a:rPr>
+              <a:t>Grossman, Park, Dhawan, et al. </a:t>
+            </a:r>
+            <a:pPr indent="0" marL="0">
+              <a:lnSpc>
+                <a:spcPct val="105000"/>
+              </a:lnSpc>
+              <a:spcAft>
+                <a:spcPts val="300"/>
+              </a:spcAft>
+              <a:buNone/>
+            </a:pPr>
+            <a:r>
+              <a:rPr lang="en-US" sz="950" dirty="0">
+                <a:solidFill>
+                  <a:srgbClr val="0F1B2D"/>
+                </a:solidFill>
+                <a:latin typeface="Calibri" pitchFamily="34" charset="0"/>
+                <a:ea typeface="Calibri" pitchFamily="34" charset="-122"/>
+                <a:cs typeface="Calibri" pitchFamily="34" charset="-120"/>
+              </a:rPr>
+              <a:t>SPGISpeech 2.0: Transcribed multi-speaker financial audio for speaker-tagged transcription. </a:t>
+            </a:r>
+            <a:pPr indent="0" marL="0">
+              <a:lnSpc>
+                <a:spcPct val="105000"/>
+              </a:lnSpc>
+              <a:spcAft>
+                <a:spcPts val="300"/>
+              </a:spcAft>
+              <a:buNone/>
+            </a:pPr>
+            <a:r>
+              <a:rPr lang="en-US" sz="950" i="1" dirty="0">
+                <a:solidFill>
+                  <a:srgbClr val="5B6B7F"/>
+                </a:solidFill>
+                <a:latin typeface="Calibri" pitchFamily="34" charset="0"/>
+                <a:ea typeface="Calibri" pitchFamily="34" charset="-122"/>
+                <a:cs typeface="Calibri" pitchFamily="34" charset="-120"/>
+              </a:rPr>
+              <a:t>arXiv:2508.05554, 2025</a:t>
+            </a:r>
+            <a:endParaRPr lang="en-US" sz="950" dirty="0"/>
+          </a:p>
+          <a:p>
+            <a:pPr indent="0" marL="0">
+              <a:lnSpc>
+                <a:spcPct val="105000"/>
+              </a:lnSpc>
+              <a:spcAft>
+                <a:spcPts val="300"/>
+              </a:spcAft>
+              <a:buNone/>
+            </a:pPr>
+            <a:r>
+              <a:rPr lang="en-US" sz="950" b="1" dirty="0">
+                <a:solidFill>
+                  <a:srgbClr val="0B7F8A"/>
+                </a:solidFill>
+                <a:latin typeface="Calibri" pitchFamily="34" charset="0"/>
+                <a:ea typeface="Calibri" pitchFamily="34" charset="-122"/>
+                <a:cs typeface="Calibri" pitchFamily="34" charset="-120"/>
+              </a:rPr>
+              <a:t>[16]  </a:t>
+            </a:r>
+            <a:pPr indent="0" marL="0">
+              <a:lnSpc>
+                <a:spcPct val="105000"/>
+              </a:lnSpc>
+              <a:spcAft>
+                <a:spcPts val="300"/>
+              </a:spcAft>
+              <a:buNone/>
+            </a:pPr>
+            <a:r>
+              <a:rPr lang="en-US" sz="950" dirty="0">
+                <a:solidFill>
+                  <a:srgbClr val="1B2A41"/>
+                </a:solidFill>
+                <a:latin typeface="Calibri" pitchFamily="34" charset="0"/>
+                <a:ea typeface="Calibri" pitchFamily="34" charset="-122"/>
+                <a:cs typeface="Calibri" pitchFamily="34" charset="-120"/>
+              </a:rPr>
+              <a:t>Shao. </a:t>
+            </a:r>
+            <a:pPr indent="0" marL="0">
+              <a:lnSpc>
+                <a:spcPct val="105000"/>
+              </a:lnSpc>
+              <a:spcAft>
+                <a:spcPts val="300"/>
+              </a:spcAft>
+              <a:buNone/>
+            </a:pPr>
+            <a:r>
+              <a:rPr lang="en-US" sz="950" dirty="0">
+                <a:solidFill>
+                  <a:srgbClr val="0F1B2D"/>
+                </a:solidFill>
+                <a:latin typeface="Calibri" pitchFamily="34" charset="0"/>
+                <a:ea typeface="Calibri" pitchFamily="34" charset="-122"/>
+                <a:cs typeface="Calibri" pitchFamily="34" charset="-120"/>
+              </a:rPr>
+              <a:t>YodasSpeakerPool: A richly-annotated multi-speaker dataset for voice cloning (built from Emilia-YODAS). </a:t>
+            </a:r>
+            <a:pPr indent="0" marL="0">
+              <a:lnSpc>
+                <a:spcPct val="105000"/>
+              </a:lnSpc>
+              <a:spcAft>
+                <a:spcPts val="300"/>
+              </a:spcAft>
+              <a:buNone/>
+            </a:pPr>
+            <a:r>
+              <a:rPr lang="en-US" sz="950" i="1" dirty="0">
+                <a:solidFill>
+                  <a:srgbClr val="5B6B7F"/>
+                </a:solidFill>
+                <a:latin typeface="Calibri" pitchFamily="34" charset="0"/>
+                <a:ea typeface="Calibri" pitchFamily="34" charset="-122"/>
+                <a:cs typeface="Calibri" pitchFamily="34" charset="-120"/>
+              </a:rPr>
+              <a:t>GitHub, 2026</a:t>
+            </a:r>
+            <a:endParaRPr lang="en-US" sz="950" dirty="0"/>
+          </a:p>
+          <a:p>
+            <a:pPr indent="0" marL="0">
+              <a:lnSpc>
+                <a:spcPct val="105000"/>
+              </a:lnSpc>
+              <a:spcAft>
+                <a:spcPts val="300"/>
+              </a:spcAft>
+              <a:buNone/>
+            </a:pPr>
+            <a:r>
+              <a:rPr lang="en-US" sz="950" b="1" dirty="0">
+                <a:solidFill>
+                  <a:srgbClr val="0B7F8A"/>
+                </a:solidFill>
+                <a:latin typeface="Calibri" pitchFamily="34" charset="0"/>
+                <a:ea typeface="Calibri" pitchFamily="34" charset="-122"/>
+                <a:cs typeface="Calibri" pitchFamily="34" charset="-120"/>
+              </a:rPr>
+              <a:t>[17]  </a:t>
+            </a:r>
+            <a:pPr indent="0" marL="0">
+              <a:lnSpc>
+                <a:spcPct val="105000"/>
+              </a:lnSpc>
+              <a:spcAft>
+                <a:spcPts val="300"/>
+              </a:spcAft>
+              <a:buNone/>
+            </a:pPr>
+            <a:r>
+              <a:rPr lang="en-US" sz="950" dirty="0">
+                <a:solidFill>
+                  <a:srgbClr val="1B2A41"/>
+                </a:solidFill>
+                <a:latin typeface="Calibri" pitchFamily="34" charset="0"/>
+                <a:ea typeface="Calibri" pitchFamily="34" charset="-122"/>
+                <a:cs typeface="Calibri" pitchFamily="34" charset="-120"/>
+              </a:rPr>
+              <a:t>Zheng, Cheng, Chen, Wang, Chen. </a:t>
+            </a:r>
+            <a:pPr indent="0" marL="0">
+              <a:lnSpc>
+                <a:spcPct val="105000"/>
+              </a:lnSpc>
+              <a:spcAft>
+                <a:spcPts val="300"/>
+              </a:spcAft>
+              <a:buNone/>
+            </a:pPr>
+            <a:r>
+              <a:rPr lang="en-US" sz="950" dirty="0">
+                <a:solidFill>
+                  <a:srgbClr val="0F1B2D"/>
+                </a:solidFill>
+                <a:latin typeface="Calibri" pitchFamily="34" charset="0"/>
+                <a:ea typeface="Calibri" pitchFamily="34" charset="-122"/>
+                <a:cs typeface="Calibri" pitchFamily="34" charset="-120"/>
+              </a:rPr>
+              <a:t>3D-Speaker: A large-scale multi-device, multi-distance, and multi-dialect corpus. </a:t>
+            </a:r>
+            <a:pPr indent="0" marL="0">
+              <a:lnSpc>
+                <a:spcPct val="105000"/>
+              </a:lnSpc>
+              <a:spcAft>
+                <a:spcPts val="300"/>
+              </a:spcAft>
+              <a:buNone/>
+            </a:pPr>
+            <a:r>
+              <a:rPr lang="en-US" sz="950" i="1" dirty="0">
+                <a:solidFill>
+                  <a:srgbClr val="5B6B7F"/>
+                </a:solidFill>
+                <a:latin typeface="Calibri" pitchFamily="34" charset="0"/>
+                <a:ea typeface="Calibri" pitchFamily="34" charset="-122"/>
+                <a:cs typeface="Calibri" pitchFamily="34" charset="-120"/>
+              </a:rPr>
+              <a:t>arXiv:2306.15354, 2023</a:t>
+            </a:r>
+            <a:endParaRPr lang="en-US" sz="950" dirty="0"/>
+          </a:p>
+          <a:p>
+            <a:pPr indent="0" marL="0">
+              <a:lnSpc>
+                <a:spcPct val="105000"/>
+              </a:lnSpc>
+              <a:spcAft>
+                <a:spcPts val="300"/>
+              </a:spcAft>
+              <a:buNone/>
+            </a:pPr>
+            <a:r>
+              <a:rPr lang="en-US" sz="950" b="1" dirty="0">
+                <a:solidFill>
+                  <a:srgbClr val="0B7F8A"/>
+                </a:solidFill>
+                <a:latin typeface="Calibri" pitchFamily="34" charset="0"/>
+                <a:ea typeface="Calibri" pitchFamily="34" charset="-122"/>
+                <a:cs typeface="Calibri" pitchFamily="34" charset="-120"/>
+              </a:rPr>
+              <a:t>[18]  </a:t>
+            </a:r>
+            <a:pPr indent="0" marL="0">
+              <a:lnSpc>
+                <a:spcPct val="105000"/>
+              </a:lnSpc>
+              <a:spcAft>
+                <a:spcPts val="300"/>
+              </a:spcAft>
+              <a:buNone/>
+            </a:pPr>
+            <a:r>
+              <a:rPr lang="en-US" sz="950" dirty="0">
+                <a:solidFill>
+                  <a:srgbClr val="1B2A41"/>
+                </a:solidFill>
+                <a:latin typeface="Calibri" pitchFamily="34" charset="0"/>
+                <a:ea typeface="Calibri" pitchFamily="34" charset="-122"/>
+                <a:cs typeface="Calibri" pitchFamily="34" charset="-120"/>
+              </a:rPr>
+              <a:t>Wang, Riviere, Lee, et al. </a:t>
+            </a:r>
+            <a:pPr indent="0" marL="0">
+              <a:lnSpc>
+                <a:spcPct val="105000"/>
+              </a:lnSpc>
+              <a:spcAft>
+                <a:spcPts val="300"/>
+              </a:spcAft>
+              <a:buNone/>
+            </a:pPr>
+            <a:r>
+              <a:rPr lang="en-US" sz="950" dirty="0">
+                <a:solidFill>
+                  <a:srgbClr val="0F1B2D"/>
+                </a:solidFill>
+                <a:latin typeface="Calibri" pitchFamily="34" charset="0"/>
+                <a:ea typeface="Calibri" pitchFamily="34" charset="-122"/>
+                <a:cs typeface="Calibri" pitchFamily="34" charset="-120"/>
+              </a:rPr>
+              <a:t>VoxPopuli: A large-scale multilingual speech corpus for representation learning. </a:t>
+            </a:r>
+            <a:pPr indent="0" marL="0">
+              <a:lnSpc>
+                <a:spcPct val="105000"/>
+              </a:lnSpc>
+              <a:spcAft>
+                <a:spcPts val="300"/>
+              </a:spcAft>
+              <a:buNone/>
+            </a:pPr>
+            <a:r>
+              <a:rPr lang="en-US" sz="950" i="1" dirty="0">
+                <a:solidFill>
+                  <a:srgbClr val="5B6B7F"/>
+                </a:solidFill>
+                <a:latin typeface="Calibri" pitchFamily="34" charset="0"/>
+                <a:ea typeface="Calibri" pitchFamily="34" charset="-122"/>
+                <a:cs typeface="Calibri" pitchFamily="34" charset="-120"/>
+              </a:rPr>
+              <a:t>ACL-IJCNLP 2021</a:t>
+            </a:r>
+            <a:endParaRPr lang="en-US" sz="950" dirty="0"/>
+          </a:p>
+          <a:p>
+            <a:pPr indent="0" marL="0">
+              <a:lnSpc>
+                <a:spcPct val="105000"/>
+              </a:lnSpc>
+              <a:spcAft>
+                <a:spcPts val="300"/>
+              </a:spcAft>
+              <a:buNone/>
+            </a:pPr>
+            <a:r>
+              <a:rPr lang="en-US" sz="950" b="1" dirty="0">
+                <a:solidFill>
+                  <a:srgbClr val="0B7F8A"/>
+                </a:solidFill>
+                <a:latin typeface="Calibri" pitchFamily="34" charset="0"/>
+                <a:ea typeface="Calibri" pitchFamily="34" charset="-122"/>
+                <a:cs typeface="Calibri" pitchFamily="34" charset="-120"/>
+              </a:rPr>
+              <a:t>[19]  </a:t>
+            </a:r>
+            <a:pPr indent="0" marL="0">
+              <a:lnSpc>
+                <a:spcPct val="105000"/>
+              </a:lnSpc>
+              <a:spcAft>
+                <a:spcPts val="300"/>
+              </a:spcAft>
+              <a:buNone/>
+            </a:pPr>
+            <a:r>
+              <a:rPr lang="en-US" sz="950" dirty="0">
+                <a:solidFill>
+                  <a:srgbClr val="1B2A41"/>
+                </a:solidFill>
+                <a:latin typeface="Calibri" pitchFamily="34" charset="0"/>
+                <a:ea typeface="Calibri" pitchFamily="34" charset="-122"/>
+                <a:cs typeface="Calibri" pitchFamily="34" charset="-120"/>
+              </a:rPr>
+              <a:t>Hu, Zhu, He, et al. </a:t>
+            </a:r>
+            <a:pPr indent="0" marL="0">
+              <a:lnSpc>
+                <a:spcPct val="105000"/>
+              </a:lnSpc>
+              <a:spcAft>
+                <a:spcPts val="300"/>
+              </a:spcAft>
+              <a:buNone/>
+            </a:pPr>
+            <a:r>
+              <a:rPr lang="en-US" sz="950" dirty="0">
+                <a:solidFill>
+                  <a:srgbClr val="0F1B2D"/>
+                </a:solidFill>
+                <a:latin typeface="Calibri" pitchFamily="34" charset="0"/>
+                <a:ea typeface="Calibri" pitchFamily="34" charset="-122"/>
+                <a:cs typeface="Calibri" pitchFamily="34" charset="-120"/>
+              </a:rPr>
+              <a:t>Qwen3-TTS technical report. </a:t>
+            </a:r>
+            <a:pPr indent="0" marL="0">
+              <a:lnSpc>
+                <a:spcPct val="105000"/>
+              </a:lnSpc>
+              <a:spcAft>
+                <a:spcPts val="300"/>
+              </a:spcAft>
+              <a:buNone/>
+            </a:pPr>
+            <a:r>
+              <a:rPr lang="en-US" sz="950" i="1" dirty="0">
+                <a:solidFill>
+                  <a:srgbClr val="5B6B7F"/>
+                </a:solidFill>
+                <a:latin typeface="Calibri" pitchFamily="34" charset="0"/>
+                <a:ea typeface="Calibri" pitchFamily="34" charset="-122"/>
+                <a:cs typeface="Calibri" pitchFamily="34" charset="-120"/>
+              </a:rPr>
+              <a:t>arXiv:2601.15621, 2026</a:t>
+            </a:r>
+            <a:endParaRPr lang="en-US" sz="950" dirty="0"/>
+          </a:p>
+          <a:p>
+            <a:pPr indent="0" marL="0">
+              <a:lnSpc>
+                <a:spcPct val="105000"/>
+              </a:lnSpc>
+              <a:spcAft>
+                <a:spcPts val="300"/>
+              </a:spcAft>
+              <a:buNone/>
+            </a:pPr>
+            <a:r>
+              <a:rPr lang="en-US" sz="950" b="1" dirty="0">
+                <a:solidFill>
+                  <a:srgbClr val="0B7F8A"/>
+                </a:solidFill>
+                <a:latin typeface="Calibri" pitchFamily="34" charset="0"/>
+                <a:ea typeface="Calibri" pitchFamily="34" charset="-122"/>
+                <a:cs typeface="Calibri" pitchFamily="34" charset="-120"/>
+              </a:rPr>
+              <a:t>[20]  </a:t>
+            </a:r>
+            <a:pPr indent="0" marL="0">
+              <a:lnSpc>
+                <a:spcPct val="105000"/>
+              </a:lnSpc>
+              <a:spcAft>
+                <a:spcPts val="300"/>
+              </a:spcAft>
+              <a:buNone/>
+            </a:pPr>
+            <a:r>
+              <a:rPr lang="en-US" sz="950" dirty="0">
+                <a:solidFill>
+                  <a:srgbClr val="1B2A41"/>
+                </a:solidFill>
+                <a:latin typeface="Calibri" pitchFamily="34" charset="0"/>
+                <a:ea typeface="Calibri" pitchFamily="34" charset="-122"/>
+                <a:cs typeface="Calibri" pitchFamily="34" charset="-120"/>
+              </a:rPr>
+              <a:t>Du, Gao, Wang, et al. </a:t>
+            </a:r>
+            <a:pPr indent="0" marL="0">
+              <a:lnSpc>
+                <a:spcPct val="105000"/>
+              </a:lnSpc>
+              <a:spcAft>
+                <a:spcPts val="300"/>
+              </a:spcAft>
+              <a:buNone/>
+            </a:pPr>
+            <a:r>
+              <a:rPr lang="en-US" sz="950" dirty="0">
+                <a:solidFill>
+                  <a:srgbClr val="0F1B2D"/>
+                </a:solidFill>
+                <a:latin typeface="Calibri" pitchFamily="34" charset="0"/>
+                <a:ea typeface="Calibri" pitchFamily="34" charset="-122"/>
+                <a:cs typeface="Calibri" pitchFamily="34" charset="-120"/>
+              </a:rPr>
+              <a:t>CosyVoice 3: Towards in-the-wild speech generation via scaling-up and post-training. </a:t>
+            </a:r>
+            <a:pPr indent="0" marL="0">
+              <a:lnSpc>
+                <a:spcPct val="105000"/>
+              </a:lnSpc>
+              <a:spcAft>
+                <a:spcPts val="300"/>
+              </a:spcAft>
+              <a:buNone/>
+            </a:pPr>
+            <a:r>
+              <a:rPr lang="en-US" sz="950" i="1" dirty="0">
+                <a:solidFill>
+                  <a:srgbClr val="5B6B7F"/>
+                </a:solidFill>
+                <a:latin typeface="Calibri" pitchFamily="34" charset="0"/>
+                <a:ea typeface="Calibri" pitchFamily="34" charset="-122"/>
+                <a:cs typeface="Calibri" pitchFamily="34" charset="-120"/>
+              </a:rPr>
+              <a:t>arXiv:2505.17589, 2025</a:t>
+            </a:r>
+            <a:endParaRPr lang="en-US" sz="950" dirty="0"/>
+          </a:p>
+          <a:p>
+            <a:pPr indent="0" marL="0">
+              <a:lnSpc>
+                <a:spcPct val="105000"/>
+              </a:lnSpc>
+              <a:spcAft>
+                <a:spcPts val="300"/>
+              </a:spcAft>
+              <a:buNone/>
+            </a:pPr>
+            <a:r>
+              <a:rPr lang="en-US" sz="950" b="1" dirty="0">
+                <a:solidFill>
+                  <a:srgbClr val="0B7F8A"/>
+                </a:solidFill>
+                <a:latin typeface="Calibri" pitchFamily="34" charset="0"/>
+                <a:ea typeface="Calibri" pitchFamily="34" charset="-122"/>
+                <a:cs typeface="Calibri" pitchFamily="34" charset="-120"/>
+              </a:rPr>
+              <a:t>[21]  </a:t>
+            </a:r>
+            <a:pPr indent="0" marL="0">
+              <a:lnSpc>
+                <a:spcPct val="105000"/>
+              </a:lnSpc>
+              <a:spcAft>
+                <a:spcPts val="300"/>
+              </a:spcAft>
+              <a:buNone/>
+            </a:pPr>
+            <a:r>
+              <a:rPr lang="en-US" sz="950" dirty="0">
+                <a:solidFill>
+                  <a:srgbClr val="1B2A41"/>
+                </a:solidFill>
+                <a:latin typeface="Calibri" pitchFamily="34" charset="0"/>
+                <a:ea typeface="Calibri" pitchFamily="34" charset="-122"/>
+                <a:cs typeface="Calibri" pitchFamily="34" charset="-120"/>
+              </a:rPr>
+              <a:t>Wu, Yan, Hu, et al. </a:t>
+            </a:r>
+            <a:pPr indent="0" marL="0">
+              <a:lnSpc>
+                <a:spcPct val="105000"/>
+              </a:lnSpc>
+              <a:spcAft>
+                <a:spcPts val="300"/>
+              </a:spcAft>
+              <a:buNone/>
+            </a:pPr>
+            <a:r>
+              <a:rPr lang="en-US" sz="950" dirty="0">
+                <a:solidFill>
+                  <a:srgbClr val="0F1B2D"/>
+                </a:solidFill>
+                <a:latin typeface="Calibri" pitchFamily="34" charset="0"/>
+                <a:ea typeface="Calibri" pitchFamily="34" charset="-122"/>
+                <a:cs typeface="Calibri" pitchFamily="34" charset="-120"/>
+              </a:rPr>
+              <a:t>Step-Audio 2 technical report. </a:t>
+            </a:r>
+            <a:pPr indent="0" marL="0">
+              <a:lnSpc>
+                <a:spcPct val="105000"/>
+              </a:lnSpc>
+              <a:spcAft>
+                <a:spcPts val="300"/>
+              </a:spcAft>
+              <a:buNone/>
+            </a:pPr>
+            <a:r>
+              <a:rPr lang="en-US" sz="950" i="1" dirty="0">
+                <a:solidFill>
+                  <a:srgbClr val="5B6B7F"/>
+                </a:solidFill>
+                <a:latin typeface="Calibri" pitchFamily="34" charset="0"/>
+                <a:ea typeface="Calibri" pitchFamily="34" charset="-122"/>
+                <a:cs typeface="Calibri" pitchFamily="34" charset="-120"/>
+              </a:rPr>
+              <a:t>arXiv:2507.16632, 2025</a:t>
+            </a:r>
+            <a:endParaRPr lang="en-US" sz="950" dirty="0"/>
+          </a:p>
+          <a:p>
+            <a:pPr indent="0" marL="0">
+              <a:lnSpc>
+                <a:spcPct val="105000"/>
+              </a:lnSpc>
+              <a:spcAft>
+                <a:spcPts val="300"/>
+              </a:spcAft>
+              <a:buNone/>
+            </a:pPr>
+            <a:r>
+              <a:rPr lang="en-US" sz="950" b="1" dirty="0">
+                <a:solidFill>
+                  <a:srgbClr val="0B7F8A"/>
+                </a:solidFill>
+                <a:latin typeface="Calibri" pitchFamily="34" charset="0"/>
+                <a:ea typeface="Calibri" pitchFamily="34" charset="-122"/>
+                <a:cs typeface="Calibri" pitchFamily="34" charset="-120"/>
+              </a:rPr>
+              <a:t>[22]  </a:t>
+            </a:r>
+            <a:pPr indent="0" marL="0">
+              <a:lnSpc>
+                <a:spcPct val="105000"/>
+              </a:lnSpc>
+              <a:spcAft>
+                <a:spcPts val="300"/>
+              </a:spcAft>
+              <a:buNone/>
+            </a:pPr>
+            <a:r>
+              <a:rPr lang="en-US" sz="950" dirty="0">
+                <a:solidFill>
+                  <a:srgbClr val="1B2A41"/>
+                </a:solidFill>
+                <a:latin typeface="Calibri" pitchFamily="34" charset="0"/>
+                <a:ea typeface="Calibri" pitchFamily="34" charset="-122"/>
+                <a:cs typeface="Calibri" pitchFamily="34" charset="-120"/>
+              </a:rPr>
+              <a:t>Goel, Ghosh, Kim, et al. </a:t>
+            </a:r>
+            <a:pPr indent="0" marL="0">
+              <a:lnSpc>
+                <a:spcPct val="105000"/>
+              </a:lnSpc>
+              <a:spcAft>
+                <a:spcPts val="300"/>
+              </a:spcAft>
+              <a:buNone/>
+            </a:pPr>
+            <a:r>
+              <a:rPr lang="en-US" sz="950" dirty="0">
+                <a:solidFill>
+                  <a:srgbClr val="0F1B2D"/>
+                </a:solidFill>
+                <a:latin typeface="Calibri" pitchFamily="34" charset="0"/>
+                <a:ea typeface="Calibri" pitchFamily="34" charset="-122"/>
+                <a:cs typeface="Calibri" pitchFamily="34" charset="-120"/>
+              </a:rPr>
+              <a:t>Audio Flamingo 3: Advancing audio intelligence with fully open large audio language models. </a:t>
+            </a:r>
+            <a:pPr indent="0" marL="0">
+              <a:lnSpc>
+                <a:spcPct val="105000"/>
+              </a:lnSpc>
+              <a:spcAft>
+                <a:spcPts val="300"/>
+              </a:spcAft>
+              <a:buNone/>
+            </a:pPr>
+            <a:r>
+              <a:rPr lang="en-US" sz="950" i="1" dirty="0">
+                <a:solidFill>
+                  <a:srgbClr val="5B6B7F"/>
+                </a:solidFill>
+                <a:latin typeface="Calibri" pitchFamily="34" charset="0"/>
+                <a:ea typeface="Calibri" pitchFamily="34" charset="-122"/>
+                <a:cs typeface="Calibri" pitchFamily="34" charset="-120"/>
+              </a:rPr>
+              <a:t>arXiv:2507.08128, 2025</a:t>
+            </a:r>
+            <a:endParaRPr lang="en-US" sz="950" dirty="0"/>
+          </a:p>
+          <a:p>
+            <a:pPr indent="0" marL="0">
+              <a:lnSpc>
+                <a:spcPct val="105000"/>
+              </a:lnSpc>
+              <a:spcAft>
+                <a:spcPts val="300"/>
+              </a:spcAft>
+              <a:buNone/>
+            </a:pPr>
+            <a:r>
+              <a:rPr lang="en-US" sz="950" b="1" dirty="0">
+                <a:solidFill>
+                  <a:srgbClr val="0B7F8A"/>
+                </a:solidFill>
+                <a:latin typeface="Calibri" pitchFamily="34" charset="0"/>
+                <a:ea typeface="Calibri" pitchFamily="34" charset="-122"/>
+                <a:cs typeface="Calibri" pitchFamily="34" charset="-120"/>
+              </a:rPr>
+              <a:t>[23]  </a:t>
+            </a:r>
+            <a:pPr indent="0" marL="0">
+              <a:lnSpc>
+                <a:spcPct val="105000"/>
+              </a:lnSpc>
+              <a:spcAft>
+                <a:spcPts val="300"/>
+              </a:spcAft>
+              <a:buNone/>
+            </a:pPr>
+            <a:r>
+              <a:rPr lang="en-US" sz="950" dirty="0">
+                <a:solidFill>
+                  <a:srgbClr val="1B2A41"/>
+                </a:solidFill>
+                <a:latin typeface="Calibri" pitchFamily="34" charset="0"/>
+                <a:ea typeface="Calibri" pitchFamily="34" charset="-122"/>
+                <a:cs typeface="Calibri" pitchFamily="34" charset="-120"/>
+              </a:rPr>
+              <a:t>Ding, Ju, Leng, et al. </a:t>
+            </a:r>
+            <a:pPr indent="0" marL="0">
+              <a:lnSpc>
+                <a:spcPct val="105000"/>
+              </a:lnSpc>
+              <a:spcAft>
+                <a:spcPts val="300"/>
+              </a:spcAft>
+              <a:buNone/>
+            </a:pPr>
+            <a:r>
+              <a:rPr lang="en-US" sz="950" dirty="0">
+                <a:solidFill>
+                  <a:srgbClr val="0F1B2D"/>
+                </a:solidFill>
+                <a:latin typeface="Calibri" pitchFamily="34" charset="0"/>
+                <a:ea typeface="Calibri" pitchFamily="34" charset="-122"/>
+                <a:cs typeface="Calibri" pitchFamily="34" charset="-120"/>
+              </a:rPr>
+              <a:t>Kimi-Audio technical report. </a:t>
+            </a:r>
+            <a:pPr indent="0" marL="0">
+              <a:lnSpc>
+                <a:spcPct val="105000"/>
+              </a:lnSpc>
+              <a:spcAft>
+                <a:spcPts val="300"/>
+              </a:spcAft>
+              <a:buNone/>
+            </a:pPr>
+            <a:r>
+              <a:rPr lang="en-US" sz="950" i="1" dirty="0">
+                <a:solidFill>
+                  <a:srgbClr val="5B6B7F"/>
+                </a:solidFill>
+                <a:latin typeface="Calibri" pitchFamily="34" charset="0"/>
+                <a:ea typeface="Calibri" pitchFamily="34" charset="-122"/>
+                <a:cs typeface="Calibri" pitchFamily="34" charset="-120"/>
+              </a:rPr>
+              <a:t>arXiv:2504.18425, 2025</a:t>
+            </a:r>
+            <a:endParaRPr lang="en-US" sz="950" dirty="0"/>
+          </a:p>
+          <a:p>
+            <a:pPr indent="0" marL="0">
+              <a:lnSpc>
+                <a:spcPct val="105000"/>
+              </a:lnSpc>
+              <a:spcAft>
+                <a:spcPts val="300"/>
+              </a:spcAft>
+              <a:buNone/>
+            </a:pPr>
+            <a:r>
+              <a:rPr lang="en-US" sz="950" b="1" dirty="0">
+                <a:solidFill>
+                  <a:srgbClr val="0B7F8A"/>
+                </a:solidFill>
+                <a:latin typeface="Calibri" pitchFamily="34" charset="0"/>
+                <a:ea typeface="Calibri" pitchFamily="34" charset="-122"/>
+                <a:cs typeface="Calibri" pitchFamily="34" charset="-120"/>
+              </a:rPr>
+              <a:t>[24]  </a:t>
+            </a:r>
+            <a:pPr indent="0" marL="0">
+              <a:lnSpc>
+                <a:spcPct val="105000"/>
+              </a:lnSpc>
+              <a:spcAft>
+                <a:spcPts val="300"/>
+              </a:spcAft>
+              <a:buNone/>
+            </a:pPr>
+            <a:r>
+              <a:rPr lang="en-US" sz="950" dirty="0">
+                <a:solidFill>
+                  <a:srgbClr val="1B2A41"/>
+                </a:solidFill>
+                <a:latin typeface="Calibri" pitchFamily="34" charset="0"/>
+                <a:ea typeface="Calibri" pitchFamily="34" charset="-122"/>
+                <a:cs typeface="Calibri" pitchFamily="34" charset="-120"/>
+              </a:rPr>
+              <a:t>Xu, Guo, Hu, et al. </a:t>
+            </a:r>
+            <a:pPr indent="0" marL="0">
+              <a:lnSpc>
+                <a:spcPct val="105000"/>
+              </a:lnSpc>
+              <a:spcAft>
+                <a:spcPts val="300"/>
+              </a:spcAft>
+              <a:buNone/>
+            </a:pPr>
+            <a:r>
+              <a:rPr lang="en-US" sz="950" dirty="0">
+                <a:solidFill>
+                  <a:srgbClr val="0F1B2D"/>
+                </a:solidFill>
+                <a:latin typeface="Calibri" pitchFamily="34" charset="0"/>
+                <a:ea typeface="Calibri" pitchFamily="34" charset="-122"/>
+                <a:cs typeface="Calibri" pitchFamily="34" charset="-120"/>
+              </a:rPr>
+              <a:t>Qwen3-Omni technical report. </a:t>
+            </a:r>
+            <a:pPr indent="0" marL="0">
+              <a:lnSpc>
+                <a:spcPct val="105000"/>
+              </a:lnSpc>
+              <a:spcAft>
+                <a:spcPts val="300"/>
+              </a:spcAft>
+              <a:buNone/>
+            </a:pPr>
+            <a:r>
+              <a:rPr lang="en-US" sz="950" i="1" dirty="0">
+                <a:solidFill>
+                  <a:srgbClr val="5B6B7F"/>
+                </a:solidFill>
+                <a:latin typeface="Calibri" pitchFamily="34" charset="0"/>
+                <a:ea typeface="Calibri" pitchFamily="34" charset="-122"/>
+                <a:cs typeface="Calibri" pitchFamily="34" charset="-120"/>
+              </a:rPr>
+              <a:t>arXiv:2509.17765, 2025</a:t>
+            </a:r>
+            <a:endParaRPr lang="en-US" sz="950" dirty="0"/>
+          </a:p>
+          <a:p>
+            <a:pPr indent="0" marL="0">
+              <a:lnSpc>
+                <a:spcPct val="105000"/>
+              </a:lnSpc>
+              <a:spcAft>
+                <a:spcPts val="300"/>
+              </a:spcAft>
+              <a:buNone/>
+            </a:pPr>
+            <a:r>
+              <a:rPr lang="en-US" sz="950" b="1" dirty="0">
+                <a:solidFill>
+                  <a:srgbClr val="0B7F8A"/>
+                </a:solidFill>
+                <a:latin typeface="Calibri" pitchFamily="34" charset="0"/>
+                <a:ea typeface="Calibri" pitchFamily="34" charset="-122"/>
+                <a:cs typeface="Calibri" pitchFamily="34" charset="-120"/>
+              </a:rPr>
+              <a:t>[25]  </a:t>
+            </a:r>
+            <a:pPr indent="0" marL="0">
+              <a:lnSpc>
+                <a:spcPct val="105000"/>
+              </a:lnSpc>
+              <a:spcAft>
+                <a:spcPts val="300"/>
+              </a:spcAft>
+              <a:buNone/>
+            </a:pPr>
+            <a:r>
+              <a:rPr lang="en-US" sz="950" dirty="0">
+                <a:solidFill>
+                  <a:srgbClr val="1B2A41"/>
+                </a:solidFill>
+                <a:latin typeface="Calibri" pitchFamily="34" charset="0"/>
+                <a:ea typeface="Calibri" pitchFamily="34" charset="-122"/>
+                <a:cs typeface="Calibri" pitchFamily="34" charset="-120"/>
+              </a:rPr>
+              <a:t>Radford, Kim, Xu, Brockman, McLeavey, Sutskever. </a:t>
+            </a:r>
+            <a:pPr indent="0" marL="0">
+              <a:lnSpc>
+                <a:spcPct val="105000"/>
+              </a:lnSpc>
+              <a:spcAft>
+                <a:spcPts val="300"/>
+              </a:spcAft>
+              <a:buNone/>
+            </a:pPr>
+            <a:r>
+              <a:rPr lang="en-US" sz="950" dirty="0">
+                <a:solidFill>
+                  <a:srgbClr val="0F1B2D"/>
+                </a:solidFill>
+                <a:latin typeface="Calibri" pitchFamily="34" charset="0"/>
+                <a:ea typeface="Calibri" pitchFamily="34" charset="-122"/>
+                <a:cs typeface="Calibri" pitchFamily="34" charset="-120"/>
+              </a:rPr>
+              <a:t>Robust speech recognition via large-scale weak supervision (Whisper). </a:t>
+            </a:r>
+            <a:pPr indent="0" marL="0">
+              <a:lnSpc>
+                <a:spcPct val="105000"/>
+              </a:lnSpc>
+              <a:spcAft>
+                <a:spcPts val="300"/>
+              </a:spcAft>
+              <a:buNone/>
+            </a:pPr>
+            <a:r>
+              <a:rPr lang="en-US" sz="950" i="1" dirty="0">
+                <a:solidFill>
+                  <a:srgbClr val="5B6B7F"/>
+                </a:solidFill>
+                <a:latin typeface="Calibri" pitchFamily="34" charset="0"/>
+                <a:ea typeface="Calibri" pitchFamily="34" charset="-122"/>
+                <a:cs typeface="Calibri" pitchFamily="34" charset="-120"/>
+              </a:rPr>
+              <a:t>ICML 2023</a:t>
+            </a:r>
+            <a:endParaRPr lang="en-US" sz="950" dirty="0"/>
+          </a:p>
+          <a:p>
+            <a:pPr indent="0" marL="0">
+              <a:lnSpc>
+                <a:spcPct val="105000"/>
+              </a:lnSpc>
+              <a:spcAft>
+                <a:spcPts val="300"/>
+              </a:spcAft>
+              <a:buNone/>
+            </a:pPr>
+            <a:r>
+              <a:rPr lang="en-US" sz="950" b="1" dirty="0">
+                <a:solidFill>
+                  <a:srgbClr val="0B7F8A"/>
+                </a:solidFill>
+                <a:latin typeface="Calibri" pitchFamily="34" charset="0"/>
+                <a:ea typeface="Calibri" pitchFamily="34" charset="-122"/>
+                <a:cs typeface="Calibri" pitchFamily="34" charset="-120"/>
+              </a:rPr>
+              <a:t>[26]  </a:t>
+            </a:r>
+            <a:pPr indent="0" marL="0">
+              <a:lnSpc>
+                <a:spcPct val="105000"/>
+              </a:lnSpc>
+              <a:spcAft>
+                <a:spcPts val="300"/>
+              </a:spcAft>
+              <a:buNone/>
+            </a:pPr>
+            <a:r>
+              <a:rPr lang="en-US" sz="950" dirty="0">
+                <a:solidFill>
+                  <a:srgbClr val="1B2A41"/>
+                </a:solidFill>
+                <a:latin typeface="Calibri" pitchFamily="34" charset="0"/>
+                <a:ea typeface="Calibri" pitchFamily="34" charset="-122"/>
+                <a:cs typeface="Calibri" pitchFamily="34" charset="-120"/>
+              </a:rPr>
+              <a:t>Yang, Li, Yang, et al. </a:t>
+            </a:r>
+            <a:pPr indent="0" marL="0">
+              <a:lnSpc>
+                <a:spcPct val="105000"/>
+              </a:lnSpc>
+              <a:spcAft>
+                <a:spcPts val="300"/>
+              </a:spcAft>
+              <a:buNone/>
+            </a:pPr>
+            <a:r>
+              <a:rPr lang="en-US" sz="950" dirty="0">
+                <a:solidFill>
+                  <a:srgbClr val="0F1B2D"/>
+                </a:solidFill>
+                <a:latin typeface="Calibri" pitchFamily="34" charset="0"/>
+                <a:ea typeface="Calibri" pitchFamily="34" charset="-122"/>
+                <a:cs typeface="Calibri" pitchFamily="34" charset="-120"/>
+              </a:rPr>
+              <a:t>Qwen3 technical report. </a:t>
+            </a:r>
+            <a:pPr indent="0" marL="0">
+              <a:lnSpc>
+                <a:spcPct val="105000"/>
+              </a:lnSpc>
+              <a:spcAft>
+                <a:spcPts val="300"/>
+              </a:spcAft>
+              <a:buNone/>
+            </a:pPr>
+            <a:r>
+              <a:rPr lang="en-US" sz="950" i="1" dirty="0">
+                <a:solidFill>
+                  <a:srgbClr val="5B6B7F"/>
+                </a:solidFill>
+                <a:latin typeface="Calibri" pitchFamily="34" charset="0"/>
+                <a:ea typeface="Calibri" pitchFamily="34" charset="-122"/>
+                <a:cs typeface="Calibri" pitchFamily="34" charset="-120"/>
+              </a:rPr>
+              <a:t>arXiv:2505.09388, 2025</a:t>
+            </a:r>
+            <a:endParaRPr lang="en-US" sz="950" dirty="0"/>
+          </a:p>
+          <a:p>
+            <a:pPr indent="0" marL="0">
+              <a:lnSpc>
+                <a:spcPct val="105000"/>
+              </a:lnSpc>
+              <a:spcAft>
+                <a:spcPts val="300"/>
+              </a:spcAft>
+              <a:buNone/>
+            </a:pPr>
+            <a:r>
+              <a:rPr lang="en-US" sz="950" b="1" dirty="0">
+                <a:solidFill>
+                  <a:srgbClr val="0B7F8A"/>
+                </a:solidFill>
+                <a:latin typeface="Calibri" pitchFamily="34" charset="0"/>
+                <a:ea typeface="Calibri" pitchFamily="34" charset="-122"/>
+                <a:cs typeface="Calibri" pitchFamily="34" charset="-120"/>
+              </a:rPr>
+              <a:t>[27]  </a:t>
+            </a:r>
+            <a:pPr indent="0" marL="0">
+              <a:lnSpc>
+                <a:spcPct val="105000"/>
+              </a:lnSpc>
+              <a:spcAft>
+                <a:spcPts val="300"/>
+              </a:spcAft>
+              <a:buNone/>
+            </a:pPr>
+            <a:r>
+              <a:rPr lang="en-US" sz="950" dirty="0">
+                <a:solidFill>
+                  <a:srgbClr val="1B2A41"/>
+                </a:solidFill>
+                <a:latin typeface="Calibri" pitchFamily="34" charset="0"/>
+                <a:ea typeface="Calibri" pitchFamily="34" charset="-122"/>
+                <a:cs typeface="Calibri" pitchFamily="34" charset="-120"/>
+              </a:rPr>
+              <a:t>Kamath, Ferret, Pathak, et al. </a:t>
+            </a:r>
+            <a:pPr indent="0" marL="0">
+              <a:lnSpc>
+                <a:spcPct val="105000"/>
+              </a:lnSpc>
+              <a:spcAft>
+                <a:spcPts val="300"/>
+              </a:spcAft>
+              <a:buNone/>
+            </a:pPr>
+            <a:r>
+              <a:rPr lang="en-US" sz="950" dirty="0">
+                <a:solidFill>
+                  <a:srgbClr val="0F1B2D"/>
+                </a:solidFill>
+                <a:latin typeface="Calibri" pitchFamily="34" charset="0"/>
+                <a:ea typeface="Calibri" pitchFamily="34" charset="-122"/>
+                <a:cs typeface="Calibri" pitchFamily="34" charset="-120"/>
+              </a:rPr>
+              <a:t>Gemma 3 technical report. </a:t>
+            </a:r>
+            <a:pPr indent="0" marL="0">
+              <a:lnSpc>
+                <a:spcPct val="105000"/>
+              </a:lnSpc>
+              <a:spcAft>
+                <a:spcPts val="300"/>
+              </a:spcAft>
+              <a:buNone/>
+            </a:pPr>
+            <a:r>
+              <a:rPr lang="en-US" sz="950" i="1" dirty="0">
+                <a:solidFill>
+                  <a:srgbClr val="5B6B7F"/>
+                </a:solidFill>
+                <a:latin typeface="Calibri" pitchFamily="34" charset="0"/>
+                <a:ea typeface="Calibri" pitchFamily="34" charset="-122"/>
+                <a:cs typeface="Calibri" pitchFamily="34" charset="-120"/>
+              </a:rPr>
+              <a:t>arXiv:2503.19786, 2025</a:t>
+            </a:r>
+            <a:endParaRPr lang="en-US" sz="950" dirty="0"/>
+          </a:p>
+          <a:p>
+            <a:pPr indent="0" marL="0">
+              <a:lnSpc>
+                <a:spcPct val="105000"/>
+              </a:lnSpc>
+              <a:spcAft>
+                <a:spcPts val="300"/>
+              </a:spcAft>
+              <a:buNone/>
+            </a:pPr>
+            <a:r>
+              <a:rPr lang="en-US" sz="950" b="1" dirty="0">
+                <a:solidFill>
+                  <a:srgbClr val="0B7F8A"/>
+                </a:solidFill>
+                <a:latin typeface="Calibri" pitchFamily="34" charset="0"/>
+                <a:ea typeface="Calibri" pitchFamily="34" charset="-122"/>
+                <a:cs typeface="Calibri" pitchFamily="34" charset="-120"/>
+              </a:rPr>
+              <a:t>[28]  </a:t>
+            </a:r>
+            <a:pPr indent="0" marL="0">
+              <a:lnSpc>
+                <a:spcPct val="105000"/>
+              </a:lnSpc>
+              <a:spcAft>
+                <a:spcPts val="300"/>
+              </a:spcAft>
+              <a:buNone/>
+            </a:pPr>
+            <a:r>
+              <a:rPr lang="en-US" sz="950" dirty="0">
+                <a:solidFill>
+                  <a:srgbClr val="1B2A41"/>
+                </a:solidFill>
+                <a:latin typeface="Calibri" pitchFamily="34" charset="0"/>
+                <a:ea typeface="Calibri" pitchFamily="34" charset="-122"/>
+                <a:cs typeface="Calibri" pitchFamily="34" charset="-120"/>
+              </a:rPr>
+              <a:t>Reddy, Beyrami, Pool, Cutler, Srinivasan, Gehrke. </a:t>
+            </a:r>
+            <a:pPr indent="0" marL="0">
+              <a:lnSpc>
+                <a:spcPct val="105000"/>
+              </a:lnSpc>
+              <a:spcAft>
+                <a:spcPts val="300"/>
+              </a:spcAft>
+              <a:buNone/>
+            </a:pPr>
+            <a:r>
+              <a:rPr lang="en-US" sz="950" dirty="0">
+                <a:solidFill>
+                  <a:srgbClr val="0F1B2D"/>
+                </a:solidFill>
+                <a:latin typeface="Calibri" pitchFamily="34" charset="0"/>
+                <a:ea typeface="Calibri" pitchFamily="34" charset="-122"/>
+                <a:cs typeface="Calibri" pitchFamily="34" charset="-120"/>
+              </a:rPr>
+              <a:t>A scalable noisy speech dataset and online subjective test framework (MS-SNSD). </a:t>
+            </a:r>
+            <a:pPr indent="0" marL="0">
+              <a:lnSpc>
+                <a:spcPct val="105000"/>
+              </a:lnSpc>
+              <a:spcAft>
+                <a:spcPts val="300"/>
+              </a:spcAft>
+              <a:buNone/>
+            </a:pPr>
+            <a:r>
+              <a:rPr lang="en-US" sz="950" i="1" dirty="0">
+                <a:solidFill>
+                  <a:srgbClr val="5B6B7F"/>
+                </a:solidFill>
+                <a:latin typeface="Calibri" pitchFamily="34" charset="0"/>
+                <a:ea typeface="Calibri" pitchFamily="34" charset="-122"/>
+                <a:cs typeface="Calibri" pitchFamily="34" charset="-120"/>
+              </a:rPr>
+              <a:t>arXiv:1909.08050, 2019</a:t>
+            </a:r>
+            <a:endParaRPr lang="en-US" sz="950" dirty="0"/>
+          </a:p>
+        </p:txBody>
+      </p:sp>
+      <p:sp>
+        <p:nvSpPr>
+          <p:cNvPr id="16" name="Text 13"/>
+          <p:cNvSpPr txBox="1"/>
+          <p:nvPr/>
+        </p:nvSpPr>
+        <p:spPr>
+          <a:xfrm>
+            <a:off x="548640" y="6199632"/>
+            <a:ext cx="11064240" cy="256032"/>
+          </a:xfrm>
+          <a:prstGeom prst="rect">
+            <a:avLst/>
+          </a:prstGeom>
+          <a:noFill/>
+          <a:ln/>
+        </p:spPr>
+        <p:txBody>
+          <a:bodyPr wrap="square" lIns="0" tIns="0" rIns="0" bIns="0" rtlCol="0" anchor="t"/>
+          <a:lstStyle/>
+          <a:p>
+            <a:pPr indent="0" marL="0">
+              <a:buNone/>
+            </a:pPr>
+            <a:r>
+              <a:rPr lang="en-US" sz="1000" i="1" dirty="0">
+                <a:solidFill>
+                  <a:srgbClr val="5B6B7F"/>
+                </a:solidFill>
+                <a:latin typeface="Calibri" pitchFamily="34" charset="0"/>
+                <a:ea typeface="Calibri" pitchFamily="34" charset="-122"/>
+                <a:cs typeface="Calibri" pitchFamily="34" charset="-120"/>
+              </a:rPr>
+              <a:t>Full bibliography in the paper: arXiv:2604.22821</a:t>
+            </a:r>
+            <a:endParaRPr lang="en-US" sz="1000" dirty="0"/>
+          </a:p>
+        </p:txBody>
+      </p:sp>
+    </p:spTree>
+  </p:cSld>
+  <p:clrMapOvr>
+    <a:masterClrMapping/>
+  </p:clrMapOvr>
+</p:sld>
+</file>
+
 <file path=ppt/slides/slide3.xml><?xml version="1.0" encoding="utf-8"?>
 <p:sld xmlns:a="http://schemas.openxmlformats.org/drawingml/2006/main" xmlns:r="http://schemas.openxmlformats.org/officeDocument/2006/relationships" xmlns:p="http://schemas.openxmlformats.org/presentationml/2006/main">
   <p:cSld name="Slide 3">

</xml_diff>

<commit_message>
Add inline citation numbers linking slides to the references slide
Places bracketed reference numbers next to every benchmark, corpus,
model and noise-set name on the talk and backup slides so they resolve
against the references slide, which uses the paper's numbering. Widens
the first column of the benchmark comparison table so the citations sit
on one line; refreshes the PDF export and reference notes.

Co-Authored-By: Claude Fable 5.1 <noreply@anthropic.com>
Claude-Session: https://claude.ai/code/session_01MbMqhsHfGDgMztoj6KvhmM
</commit_message>
<xml_diff>
--- a/presentation/Audio2Tool_Interspeech2026_Oral.pptx
+++ b/presentation/Audio2Tool_Interspeech2026_Oral.pptx
@@ -7414,7 +7414,7 @@
                 <a:ea typeface="Calibri" pitchFamily="34" charset="-122"/>
                 <a:cs typeface="Calibri" pitchFamily="34" charset="-120"/>
               </a:rPr>
-              <a:t>SPGISpeech 2.0 · Emilia-YODAS · 3D-Speaker · VoxPopuli</a:t>
+              <a:t>SPGISpeech 2.0 [15] · Emilia-YODAS [16] · 3D-Speaker [17] · VoxPopuli [18]</a:t>
             </a:r>
             <a:endParaRPr lang="en-US" sz="1200" dirty="0"/>
           </a:p>
@@ -7772,7 +7772,7 @@
                 <a:ea typeface="Calibri" pitchFamily="34" charset="-122"/>
                 <a:cs typeface="Calibri" pitchFamily="34" charset="-120"/>
               </a:rPr>
-              <a:t>Qwen3-TTS and CosyVoice-3 render every query in m sampled voices</a:t>
+              <a:t>Qwen3-TTS [19] and CosyVoice-3 [20] render every query in m sampled voices</a:t>
             </a:r>
             <a:endParaRPr lang="en-US" sz="1200" dirty="0"/>
           </a:p>
@@ -8019,9 +8019,9 @@
             <a:tbl>
               <a:tblPr/>
               <a:tblGrid>
-                <a:gridCol w="1417320"/>
-                <a:gridCol w="1051560"/>
-                <a:gridCol w="1673352"/>
+                <a:gridCol w="1691640"/>
+                <a:gridCol w="914400"/>
+                <a:gridCol w="1536192"/>
                 <a:gridCol w="868680"/>
               </a:tblGrid>
               <a:tr h="384048">
@@ -8316,7 +8316,7 @@
                           <a:ea typeface="Calibri" pitchFamily="34" charset="-122"/>
                           <a:cs typeface="Calibri" pitchFamily="34" charset="-120"/>
                         </a:rPr>
-                        <a:t>SPGISpeech 2.0</a:t>
+                        <a:t>SPGISpeech 2.0 [15]</a:t>
                       </a:r>
                       <a:endParaRPr lang="en-US" sz="1250" dirty="0">
                         <a:latin typeface="Calibri" charset="0"/>
@@ -8446,7 +8446,7 @@
                           <a:ea typeface="Calibri" pitchFamily="34" charset="-122"/>
                           <a:cs typeface="Calibri" pitchFamily="34" charset="-120"/>
                         </a:rPr>
-                        <a:t>US, Asia, Latin America</a:t>
+                        <a:t>US, Asia, LatAm</a:t>
                       </a:r>
                       <a:endParaRPr lang="en-US" sz="1250" dirty="0">
                         <a:latin typeface="Calibri" charset="0"/>
@@ -8578,7 +8578,7 @@
                           <a:ea typeface="Calibri" pitchFamily="34" charset="-122"/>
                           <a:cs typeface="Calibri" pitchFamily="34" charset="-120"/>
                         </a:rPr>
-                        <a:t>Emilia-YODAS</a:t>
+                        <a:t>Emilia-YODAS [16]</a:t>
                       </a:r>
                       <a:endParaRPr lang="en-US" sz="1250" dirty="0">
                         <a:latin typeface="Calibri" charset="0"/>
@@ -8840,7 +8840,7 @@
                           <a:ea typeface="Calibri" pitchFamily="34" charset="-122"/>
                           <a:cs typeface="Calibri" pitchFamily="34" charset="-120"/>
                         </a:rPr>
-                        <a:t>3D-Speaker</a:t>
+                        <a:t>3D-Speaker [17]</a:t>
                       </a:r>
                       <a:endParaRPr lang="en-US" sz="1250" dirty="0">
                         <a:latin typeface="Calibri" charset="0"/>
@@ -9102,7 +9102,7 @@
                           <a:ea typeface="Calibri" pitchFamily="34" charset="-122"/>
                           <a:cs typeface="Calibri" pitchFamily="34" charset="-120"/>
                         </a:rPr>
-                        <a:t>VoxPopuli</a:t>
+                        <a:t>VoxPopuli [18]</a:t>
                       </a:r>
                       <a:endParaRPr lang="en-US" sz="1250" dirty="0">
                         <a:latin typeface="Calibri" charset="0"/>
@@ -10318,7 +10318,7 @@
                 <a:ea typeface="Calibri" pitchFamily="34" charset="-122"/>
                 <a:cs typeface="Calibri" pitchFamily="34" charset="-120"/>
               </a:rPr>
-              <a:t>Qwen3-Omni-30B  ·  Qwen2.5-Omni-7B  ·  Kimi-Audio-7B</a:t>
+              <a:t>Qwen3-Omni-30B [24]  ·  Qwen2.5-Omni-7B [24]  ·  Kimi-Audio-7B [23]</a:t>
             </a:r>
             <a:endParaRPr lang="en-US" sz="1350" dirty="0"/>
           </a:p>
@@ -10338,7 +10338,7 @@
                 <a:ea typeface="Calibri" pitchFamily="34" charset="-122"/>
                 <a:cs typeface="Calibri" pitchFamily="34" charset="-120"/>
               </a:rPr>
-              <a:t>Step-Audio-2-7B  ·  Audio-Flamingo-3-8B</a:t>
+              <a:t>Step-Audio-2-7B [21]  ·  Audio-Flamingo-3-8B [22]</a:t>
             </a:r>
             <a:endParaRPr lang="en-US" sz="1350" dirty="0"/>
           </a:p>
@@ -10492,7 +10492,7 @@
                 <a:ea typeface="Calibri" pitchFamily="34" charset="-122"/>
                 <a:cs typeface="Calibri" pitchFamily="34" charset="-120"/>
               </a:rPr>
-              <a:t>Cascaded  ·  audio → Whisper-v3 → text LLM</a:t>
+              <a:t>Cascaded  ·  audio → Whisper-v3 [25] → text LLM</a:t>
             </a:r>
             <a:endParaRPr lang="en-US" sz="1500" dirty="0"/>
           </a:p>
@@ -10531,7 +10531,7 @@
                 <a:ea typeface="Calibri" pitchFamily="34" charset="-122"/>
                 <a:cs typeface="Calibri" pitchFamily="34" charset="-120"/>
               </a:rPr>
-              <a:t>Qwen3 1.7B / 4B / 8B  ·  Gemma-3 12B / 27B</a:t>
+              <a:t>Qwen3 1.7B / 4B / 8B [26]  ·  Gemma-3 12B / 27B [27]</a:t>
             </a:r>
             <a:endParaRPr lang="en-US" sz="1350" dirty="0"/>
           </a:p>
@@ -13948,7 +13948,7 @@
                 <a:ea typeface="Calibri" pitchFamily="34" charset="-122"/>
                 <a:cs typeface="Calibri" pitchFamily="34" charset="-120"/>
               </a:rPr>
-              <a:t>Babble, mechanical hum, impulsive (MS-SNSD) at +15, +5 and −5 dB</a:t>
+              <a:t>Babble, mechanical hum, impulsive (MS-SNSD [28]) at +15, +5 and −5 dB</a:t>
             </a:r>
             <a:endParaRPr lang="en-US" sz="1250" dirty="0"/>
           </a:p>
@@ -20509,7 +20509,7 @@
                           <a:ea typeface="Calibri" pitchFamily="34" charset="-122"/>
                           <a:cs typeface="Calibri" pitchFamily="34" charset="-120"/>
                         </a:rPr>
-                        <a:t>ATIS</a:t>
+                        <a:t>ATIS [6]</a:t>
                       </a:r>
                       <a:endParaRPr lang="en-US" sz="1400" dirty="0">
                         <a:latin typeface="Calibri" charset="0"/>
@@ -20901,7 +20901,7 @@
                           <a:ea typeface="Calibri" pitchFamily="34" charset="-122"/>
                           <a:cs typeface="Calibri" pitchFamily="34" charset="-120"/>
                         </a:rPr>
-                        <a:t>SNIPS</a:t>
+                        <a:t>SNIPS [12]</a:t>
                       </a:r>
                       <a:endParaRPr lang="en-US" sz="1400" dirty="0">
                         <a:latin typeface="Calibri" charset="0"/>
@@ -21685,7 +21685,7 @@
                           <a:ea typeface="Calibri" pitchFamily="34" charset="-122"/>
                           <a:cs typeface="Calibri" pitchFamily="34" charset="-120"/>
                         </a:rPr>
-                        <a:t>SLURP</a:t>
+                        <a:t>SLURP [7]</a:t>
                       </a:r>
                       <a:endParaRPr lang="en-US" sz="1400" dirty="0">
                         <a:latin typeface="Calibri" charset="0"/>
@@ -22077,7 +22077,7 @@
                           <a:ea typeface="Calibri" pitchFamily="34" charset="-122"/>
                           <a:cs typeface="Calibri" pitchFamily="34" charset="-120"/>
                         </a:rPr>
-                        <a:t>MixATIS</a:t>
+                        <a:t>MixATIS [13]</a:t>
                       </a:r>
                       <a:endParaRPr lang="en-US" sz="1400" dirty="0">
                         <a:latin typeface="Calibri" charset="0"/>
@@ -22469,7 +22469,7 @@
                           <a:ea typeface="Calibri" pitchFamily="34" charset="-122"/>
                           <a:cs typeface="Calibri" pitchFamily="34" charset="-120"/>
                         </a:rPr>
-                        <a:t>MixSNIPS</a:t>
+                        <a:t>MixSNIPS [14]</a:t>
                       </a:r>
                       <a:endParaRPr lang="en-US" sz="1400" dirty="0">
                         <a:latin typeface="Calibri" charset="0"/>
@@ -22861,7 +22861,7 @@
                           <a:ea typeface="Calibri" pitchFamily="34" charset="-122"/>
                           <a:cs typeface="Calibri" pitchFamily="34" charset="-120"/>
                         </a:rPr>
-                        <a:t>MAC-SLU</a:t>
+                        <a:t>MAC-SLU [9]</a:t>
                       </a:r>
                       <a:endParaRPr lang="en-US" sz="1400" dirty="0">
                         <a:latin typeface="Calibri" charset="0"/>
@@ -24385,7 +24385,7 @@
                 <a:ea typeface="Calibri" pitchFamily="34" charset="-122"/>
                 <a:cs typeface="Calibri" pitchFamily="34" charset="-120"/>
               </a:rPr>
-              <a:t>Qwen3-TTS · CosyVoice-3, zero-shot voice cloning; noise mixed per Algorithm 1</a:t>
+              <a:t>Qwen3-TTS [19] · CosyVoice-3 [20], zero-shot voice cloning; noise mixed per Algorithm 1</a:t>
             </a:r>
             <a:endParaRPr lang="en-US" sz="1300" dirty="0"/>
           </a:p>
@@ -27169,7 +27169,7 @@
                 <a:ea typeface="Calibri" pitchFamily="34" charset="-122"/>
                 <a:cs typeface="Calibri" pitchFamily="34" charset="-120"/>
               </a:rPr>
-              <a:t>Full bibliography in the paper: arXiv:2604.22821</a:t>
+              <a:t>Numbers match the bracketed citations on the earlier slides and in the paper (arXiv:2604.22821).</a:t>
             </a:r>
             <a:endParaRPr lang="en-US" sz="1000" dirty="0"/>
           </a:p>
@@ -30205,12 +30205,12 @@
             <a:tbl>
               <a:tblPr/>
               <a:tblGrid>
-                <a:gridCol w="3044952"/>
-                <a:gridCol w="1463040"/>
-                <a:gridCol w="1737360"/>
-                <a:gridCol w="1737360"/>
-                <a:gridCol w="1554480"/>
-                <a:gridCol w="1554480"/>
+                <a:gridCol w="3337560"/>
+                <a:gridCol w="1371600"/>
+                <a:gridCol w="1691640"/>
+                <a:gridCol w="1691640"/>
+                <a:gridCol w="1499616"/>
+                <a:gridCol w="1499616"/>
               </a:tblGrid>
               <a:tr h="502920">
                 <a:tc>
@@ -30650,7 +30650,7 @@
                           <a:ea typeface="Calibri" pitchFamily="34" charset="-122"/>
                           <a:cs typeface="Calibri" pitchFamily="34" charset="-120"/>
                         </a:rPr>
-                        <a:t>BFCL, ComplexFuncBench</a:t>
+                        <a:t>BFCL [3], ComplexFuncBench [2]</a:t>
                       </a:r>
                       <a:endParaRPr lang="en-US" sz="1300" dirty="0">
                         <a:latin typeface="Calibri" charset="0"/>
@@ -31081,7 +31081,7 @@
                           <a:ea typeface="Calibri" pitchFamily="34" charset="-122"/>
                           <a:cs typeface="Calibri" pitchFamily="34" charset="-120"/>
                         </a:rPr>
-                        <a:t>SLURP, STOP, MAC-SLU</a:t>
+                        <a:t>SLURP [7], STOP [8], MAC-SLU [9]</a:t>
                       </a:r>
                       <a:endParaRPr lang="en-US" sz="1300" dirty="0">
                         <a:latin typeface="Calibri" charset="0"/>
@@ -31512,7 +31512,7 @@
                           <a:ea typeface="Calibri" pitchFamily="34" charset="-122"/>
                           <a:cs typeface="Calibri" pitchFamily="34" charset="-120"/>
                         </a:rPr>
-                        <a:t>BFCL-Audio, VoiceAgentBench, MFCL</a:t>
+                        <a:t>BFCL-Audio [10], VoiceAgentBench [5], MFCL [11]</a:t>
                       </a:r>
                       <a:endParaRPr lang="en-US" sz="1300" dirty="0">
                         <a:latin typeface="Calibri" charset="0"/>
@@ -32386,7 +32386,7 @@
                 <a:ea typeface="Calibri" pitchFamily="34" charset="-122"/>
                 <a:cs typeface="Calibri" pitchFamily="34" charset="-120"/>
               </a:rPr>
-              <a:t>Audio2Tool keeps the executable-call formalism of BFCL, but makes the input spoken, acoustically diverse, and organised so each tier isolates a distinct failure mode.</a:t>
+              <a:t>Audio2Tool keeps the executable-call formalism of BFCL [3], but makes the input spoken, acoustically diverse, and organised so each tier isolates a distinct failure mode.</a:t>
             </a:r>
             <a:endParaRPr lang="en-US" sz="1600" dirty="0"/>
           </a:p>

</xml_diff>